<commit_message>
chore: remove unfinished setup assistent
</commit_message>
<xml_diff>
--- a/_doku/Praesentation_TwitchLandingpage_v3.pptx
+++ b/_doku/Praesentation_TwitchLandingpage_v3.pptx
@@ -4,6 +4,9 @@
   <p:sldMasterIdLst>
     <p:sldMasterId id="2147483648" r:id="rId1"/>
   </p:sldMasterIdLst>
+  <p:notesMasterIdLst>
+    <p:notesMasterId r:id="rId11"/>
+  </p:notesMasterIdLst>
   <p:sldIdLst>
     <p:sldId id="256" r:id="rId2"/>
     <p:sldId id="257" r:id="rId3"/>
@@ -131,6 +134,439 @@
 </p:presentation>
 </file>
 
+<file path=ppt/notesMasters/notesMaster1.xml><?xml version="1.0" encoding="utf-8"?>
+<p:notesMaster xmlns:a="http://schemas.openxmlformats.org/drawingml/2006/main" xmlns:r="http://schemas.openxmlformats.org/officeDocument/2006/relationships" xmlns:p="http://schemas.openxmlformats.org/presentationml/2006/main">
+  <p:cSld>
+    <p:bg>
+      <p:bgRef idx="1001">
+        <a:schemeClr val="bg1"/>
+      </p:bgRef>
+    </p:bg>
+    <p:spTree>
+      <p:nvGrpSpPr>
+        <p:cNvPr id="1" name=""/>
+        <p:cNvGrpSpPr/>
+        <p:nvPr/>
+      </p:nvGrpSpPr>
+      <p:grpSpPr>
+        <a:xfrm>
+          <a:off x="0" y="0"/>
+          <a:ext cx="0" cy="0"/>
+          <a:chOff x="0" y="0"/>
+          <a:chExt cx="0" cy="0"/>
+        </a:xfrm>
+      </p:grpSpPr>
+      <p:sp>
+        <p:nvSpPr>
+          <p:cNvPr id="2" name="Kopfzeilenplatzhalter 1"/>
+          <p:cNvSpPr>
+            <a:spLocks noGrp="1"/>
+          </p:cNvSpPr>
+          <p:nvPr>
+            <p:ph type="hdr" sz="quarter"/>
+          </p:nvPr>
+        </p:nvSpPr>
+        <p:spPr>
+          <a:xfrm>
+            <a:off x="0" y="0"/>
+            <a:ext cx="2971800" cy="458788"/>
+          </a:xfrm>
+          <a:prstGeom prst="rect">
+            <a:avLst/>
+          </a:prstGeom>
+        </p:spPr>
+        <p:txBody>
+          <a:bodyPr vert="horz" lIns="91440" tIns="45720" rIns="91440" bIns="45720" rtlCol="0"/>
+          <a:lstStyle>
+            <a:lvl1pPr algn="l">
+              <a:defRPr sz="1200"/>
+            </a:lvl1pPr>
+          </a:lstStyle>
+          <a:p>
+            <a:endParaRPr lang="de-DE"/>
+          </a:p>
+        </p:txBody>
+      </p:sp>
+      <p:sp>
+        <p:nvSpPr>
+          <p:cNvPr id="3" name="Datumsplatzhalter 2"/>
+          <p:cNvSpPr>
+            <a:spLocks noGrp="1"/>
+          </p:cNvSpPr>
+          <p:nvPr>
+            <p:ph type="dt" idx="1"/>
+          </p:nvPr>
+        </p:nvSpPr>
+        <p:spPr>
+          <a:xfrm>
+            <a:off x="3884613" y="0"/>
+            <a:ext cx="2971800" cy="458788"/>
+          </a:xfrm>
+          <a:prstGeom prst="rect">
+            <a:avLst/>
+          </a:prstGeom>
+        </p:spPr>
+        <p:txBody>
+          <a:bodyPr vert="horz" lIns="91440" tIns="45720" rIns="91440" bIns="45720" rtlCol="0"/>
+          <a:lstStyle>
+            <a:lvl1pPr algn="r">
+              <a:defRPr sz="1200"/>
+            </a:lvl1pPr>
+          </a:lstStyle>
+          <a:p>
+            <a:fld id="{63217D73-550F-4791-BACB-97561F3B97F3}" type="datetimeFigureOut">
+              <a:rPr lang="de-DE" smtClean="0"/>
+              <a:t>11.06.2026</a:t>
+            </a:fld>
+            <a:endParaRPr lang="de-DE"/>
+          </a:p>
+        </p:txBody>
+      </p:sp>
+      <p:sp>
+        <p:nvSpPr>
+          <p:cNvPr id="4" name="Folienbildplatzhalter 3"/>
+          <p:cNvSpPr>
+            <a:spLocks noGrp="1" noRot="1" noChangeAspect="1"/>
+          </p:cNvSpPr>
+          <p:nvPr>
+            <p:ph type="sldImg" idx="2"/>
+          </p:nvPr>
+        </p:nvSpPr>
+        <p:spPr>
+          <a:xfrm>
+            <a:off x="685800" y="1143000"/>
+            <a:ext cx="5486400" cy="3086100"/>
+          </a:xfrm>
+          <a:prstGeom prst="rect">
+            <a:avLst/>
+          </a:prstGeom>
+          <a:noFill/>
+          <a:ln w="12700">
+            <a:solidFill>
+              <a:prstClr val="black"/>
+            </a:solidFill>
+          </a:ln>
+        </p:spPr>
+        <p:txBody>
+          <a:bodyPr vert="horz" lIns="91440" tIns="45720" rIns="91440" bIns="45720" rtlCol="0" anchor="ctr"/>
+          <a:lstStyle/>
+          <a:p>
+            <a:endParaRPr lang="de-DE"/>
+          </a:p>
+        </p:txBody>
+      </p:sp>
+      <p:sp>
+        <p:nvSpPr>
+          <p:cNvPr id="5" name="Notizenplatzhalter 4"/>
+          <p:cNvSpPr>
+            <a:spLocks noGrp="1"/>
+          </p:cNvSpPr>
+          <p:nvPr>
+            <p:ph type="body" sz="quarter" idx="3"/>
+          </p:nvPr>
+        </p:nvSpPr>
+        <p:spPr>
+          <a:xfrm>
+            <a:off x="685800" y="4400550"/>
+            <a:ext cx="5486400" cy="3600450"/>
+          </a:xfrm>
+          <a:prstGeom prst="rect">
+            <a:avLst/>
+          </a:prstGeom>
+        </p:spPr>
+        <p:txBody>
+          <a:bodyPr vert="horz" lIns="91440" tIns="45720" rIns="91440" bIns="45720" rtlCol="0"/>
+          <a:lstStyle/>
+          <a:p>
+            <a:pPr lvl="0"/>
+            <a:r>
+              <a:rPr lang="de-DE"/>
+              <a:t>Mastertextformat bearbeiten</a:t>
+            </a:r>
+          </a:p>
+          <a:p>
+            <a:pPr lvl="1"/>
+            <a:r>
+              <a:rPr lang="de-DE"/>
+              <a:t>Zweite Ebene</a:t>
+            </a:r>
+          </a:p>
+          <a:p>
+            <a:pPr lvl="2"/>
+            <a:r>
+              <a:rPr lang="de-DE"/>
+              <a:t>Dritte Ebene</a:t>
+            </a:r>
+          </a:p>
+          <a:p>
+            <a:pPr lvl="3"/>
+            <a:r>
+              <a:rPr lang="de-DE"/>
+              <a:t>Vierte Ebene</a:t>
+            </a:r>
+          </a:p>
+          <a:p>
+            <a:pPr lvl="4"/>
+            <a:r>
+              <a:rPr lang="de-DE"/>
+              <a:t>Fünfte Ebene</a:t>
+            </a:r>
+          </a:p>
+        </p:txBody>
+      </p:sp>
+      <p:sp>
+        <p:nvSpPr>
+          <p:cNvPr id="6" name="Fußzeilenplatzhalter 5"/>
+          <p:cNvSpPr>
+            <a:spLocks noGrp="1"/>
+          </p:cNvSpPr>
+          <p:nvPr>
+            <p:ph type="ftr" sz="quarter" idx="4"/>
+          </p:nvPr>
+        </p:nvSpPr>
+        <p:spPr>
+          <a:xfrm>
+            <a:off x="0" y="8685213"/>
+            <a:ext cx="2971800" cy="458787"/>
+          </a:xfrm>
+          <a:prstGeom prst="rect">
+            <a:avLst/>
+          </a:prstGeom>
+        </p:spPr>
+        <p:txBody>
+          <a:bodyPr vert="horz" lIns="91440" tIns="45720" rIns="91440" bIns="45720" rtlCol="0" anchor="b"/>
+          <a:lstStyle>
+            <a:lvl1pPr algn="l">
+              <a:defRPr sz="1200"/>
+            </a:lvl1pPr>
+          </a:lstStyle>
+          <a:p>
+            <a:endParaRPr lang="de-DE"/>
+          </a:p>
+        </p:txBody>
+      </p:sp>
+      <p:sp>
+        <p:nvSpPr>
+          <p:cNvPr id="7" name="Foliennummernplatzhalter 6"/>
+          <p:cNvSpPr>
+            <a:spLocks noGrp="1"/>
+          </p:cNvSpPr>
+          <p:nvPr>
+            <p:ph type="sldNum" sz="quarter" idx="5"/>
+          </p:nvPr>
+        </p:nvSpPr>
+        <p:spPr>
+          <a:xfrm>
+            <a:off x="3884613" y="8685213"/>
+            <a:ext cx="2971800" cy="458787"/>
+          </a:xfrm>
+          <a:prstGeom prst="rect">
+            <a:avLst/>
+          </a:prstGeom>
+        </p:spPr>
+        <p:txBody>
+          <a:bodyPr vert="horz" lIns="91440" tIns="45720" rIns="91440" bIns="45720" rtlCol="0" anchor="b"/>
+          <a:lstStyle>
+            <a:lvl1pPr algn="r">
+              <a:defRPr sz="1200"/>
+            </a:lvl1pPr>
+          </a:lstStyle>
+          <a:p>
+            <a:fld id="{5A09EA95-CB25-40C2-BA4C-4CC8F65AE94A}" type="slidenum">
+              <a:rPr lang="de-DE" smtClean="0"/>
+              <a:t>‹Nr.›</a:t>
+            </a:fld>
+            <a:endParaRPr lang="de-DE"/>
+          </a:p>
+        </p:txBody>
+      </p:sp>
+    </p:spTree>
+    <p:extLst>
+      <p:ext uri="{BB962C8B-B14F-4D97-AF65-F5344CB8AC3E}">
+        <p14:creationId xmlns:p14="http://schemas.microsoft.com/office/powerpoint/2010/main" val="2585645167"/>
+      </p:ext>
+    </p:extLst>
+  </p:cSld>
+  <p:clrMap bg1="lt1" tx1="dk1" bg2="lt2" tx2="dk2" accent1="accent1" accent2="accent2" accent3="accent3" accent4="accent4" accent5="accent5" accent6="accent6" hlink="hlink" folHlink="folHlink"/>
+  <p:notesStyle>
+    <a:lvl1pPr marL="0" algn="l" defTabSz="914400" rtl="0" eaLnBrk="1" latinLnBrk="0" hangingPunct="1">
+      <a:defRPr sz="1200" kern="1200">
+        <a:solidFill>
+          <a:schemeClr val="tx1"/>
+        </a:solidFill>
+        <a:latin typeface="+mn-lt"/>
+        <a:ea typeface="+mn-ea"/>
+        <a:cs typeface="+mn-cs"/>
+      </a:defRPr>
+    </a:lvl1pPr>
+    <a:lvl2pPr marL="457200" algn="l" defTabSz="914400" rtl="0" eaLnBrk="1" latinLnBrk="0" hangingPunct="1">
+      <a:defRPr sz="1200" kern="1200">
+        <a:solidFill>
+          <a:schemeClr val="tx1"/>
+        </a:solidFill>
+        <a:latin typeface="+mn-lt"/>
+        <a:ea typeface="+mn-ea"/>
+        <a:cs typeface="+mn-cs"/>
+      </a:defRPr>
+    </a:lvl2pPr>
+    <a:lvl3pPr marL="914400" algn="l" defTabSz="914400" rtl="0" eaLnBrk="1" latinLnBrk="0" hangingPunct="1">
+      <a:defRPr sz="1200" kern="1200">
+        <a:solidFill>
+          <a:schemeClr val="tx1"/>
+        </a:solidFill>
+        <a:latin typeface="+mn-lt"/>
+        <a:ea typeface="+mn-ea"/>
+        <a:cs typeface="+mn-cs"/>
+      </a:defRPr>
+    </a:lvl3pPr>
+    <a:lvl4pPr marL="1371600" algn="l" defTabSz="914400" rtl="0" eaLnBrk="1" latinLnBrk="0" hangingPunct="1">
+      <a:defRPr sz="1200" kern="1200">
+        <a:solidFill>
+          <a:schemeClr val="tx1"/>
+        </a:solidFill>
+        <a:latin typeface="+mn-lt"/>
+        <a:ea typeface="+mn-ea"/>
+        <a:cs typeface="+mn-cs"/>
+      </a:defRPr>
+    </a:lvl4pPr>
+    <a:lvl5pPr marL="1828800" algn="l" defTabSz="914400" rtl="0" eaLnBrk="1" latinLnBrk="0" hangingPunct="1">
+      <a:defRPr sz="1200" kern="1200">
+        <a:solidFill>
+          <a:schemeClr val="tx1"/>
+        </a:solidFill>
+        <a:latin typeface="+mn-lt"/>
+        <a:ea typeface="+mn-ea"/>
+        <a:cs typeface="+mn-cs"/>
+      </a:defRPr>
+    </a:lvl5pPr>
+    <a:lvl6pPr marL="2286000" algn="l" defTabSz="914400" rtl="0" eaLnBrk="1" latinLnBrk="0" hangingPunct="1">
+      <a:defRPr sz="1200" kern="1200">
+        <a:solidFill>
+          <a:schemeClr val="tx1"/>
+        </a:solidFill>
+        <a:latin typeface="+mn-lt"/>
+        <a:ea typeface="+mn-ea"/>
+        <a:cs typeface="+mn-cs"/>
+      </a:defRPr>
+    </a:lvl6pPr>
+    <a:lvl7pPr marL="2743200" algn="l" defTabSz="914400" rtl="0" eaLnBrk="1" latinLnBrk="0" hangingPunct="1">
+      <a:defRPr sz="1200" kern="1200">
+        <a:solidFill>
+          <a:schemeClr val="tx1"/>
+        </a:solidFill>
+        <a:latin typeface="+mn-lt"/>
+        <a:ea typeface="+mn-ea"/>
+        <a:cs typeface="+mn-cs"/>
+      </a:defRPr>
+    </a:lvl7pPr>
+    <a:lvl8pPr marL="3200400" algn="l" defTabSz="914400" rtl="0" eaLnBrk="1" latinLnBrk="0" hangingPunct="1">
+      <a:defRPr sz="1200" kern="1200">
+        <a:solidFill>
+          <a:schemeClr val="tx1"/>
+        </a:solidFill>
+        <a:latin typeface="+mn-lt"/>
+        <a:ea typeface="+mn-ea"/>
+        <a:cs typeface="+mn-cs"/>
+      </a:defRPr>
+    </a:lvl8pPr>
+    <a:lvl9pPr marL="3657600" algn="l" defTabSz="914400" rtl="0" eaLnBrk="1" latinLnBrk="0" hangingPunct="1">
+      <a:defRPr sz="1200" kern="1200">
+        <a:solidFill>
+          <a:schemeClr val="tx1"/>
+        </a:solidFill>
+        <a:latin typeface="+mn-lt"/>
+        <a:ea typeface="+mn-ea"/>
+        <a:cs typeface="+mn-cs"/>
+      </a:defRPr>
+    </a:lvl9pPr>
+  </p:notesStyle>
+</p:notesMaster>
+</file>
+
+<file path=ppt/notesSlides/notesSlide1.xml><?xml version="1.0" encoding="utf-8"?>
+<p:notes xmlns:a="http://schemas.openxmlformats.org/drawingml/2006/main" xmlns:r="http://schemas.openxmlformats.org/officeDocument/2006/relationships" xmlns:p="http://schemas.openxmlformats.org/presentationml/2006/main">
+  <p:cSld>
+    <p:spTree>
+      <p:nvGrpSpPr>
+        <p:cNvPr id="1" name=""/>
+        <p:cNvGrpSpPr/>
+        <p:nvPr/>
+      </p:nvGrpSpPr>
+      <p:grpSpPr>
+        <a:xfrm>
+          <a:off x="0" y="0"/>
+          <a:ext cx="0" cy="0"/>
+          <a:chOff x="0" y="0"/>
+          <a:chExt cx="0" cy="0"/>
+        </a:xfrm>
+      </p:grpSpPr>
+      <p:sp>
+        <p:nvSpPr>
+          <p:cNvPr id="2" name="Folienbildplatzhalter 1"/>
+          <p:cNvSpPr>
+            <a:spLocks noGrp="1" noRot="1" noChangeAspect="1"/>
+          </p:cNvSpPr>
+          <p:nvPr>
+            <p:ph type="sldImg"/>
+          </p:nvPr>
+        </p:nvSpPr>
+        <p:spPr/>
+      </p:sp>
+      <p:sp>
+        <p:nvSpPr>
+          <p:cNvPr id="3" name="Notizenplatzhalter 2"/>
+          <p:cNvSpPr>
+            <a:spLocks noGrp="1"/>
+          </p:cNvSpPr>
+          <p:nvPr>
+            <p:ph type="body" idx="1"/>
+          </p:nvPr>
+        </p:nvSpPr>
+        <p:spPr/>
+        <p:txBody>
+          <a:bodyPr/>
+          <a:lstStyle/>
+          <a:p>
+            <a:endParaRPr lang="de-DE" dirty="0"/>
+          </a:p>
+        </p:txBody>
+      </p:sp>
+      <p:sp>
+        <p:nvSpPr>
+          <p:cNvPr id="4" name="Foliennummernplatzhalter 3"/>
+          <p:cNvSpPr>
+            <a:spLocks noGrp="1"/>
+          </p:cNvSpPr>
+          <p:nvPr>
+            <p:ph type="sldNum" sz="quarter" idx="5"/>
+          </p:nvPr>
+        </p:nvSpPr>
+        <p:spPr/>
+        <p:txBody>
+          <a:bodyPr/>
+          <a:lstStyle/>
+          <a:p>
+            <a:fld id="{5A09EA95-CB25-40C2-BA4C-4CC8F65AE94A}" type="slidenum">
+              <a:rPr lang="de-DE" smtClean="0"/>
+              <a:t>6</a:t>
+            </a:fld>
+            <a:endParaRPr lang="de-DE"/>
+          </a:p>
+        </p:txBody>
+      </p:sp>
+    </p:spTree>
+    <p:extLst>
+      <p:ext uri="{BB962C8B-B14F-4D97-AF65-F5344CB8AC3E}">
+        <p14:creationId xmlns:p14="http://schemas.microsoft.com/office/powerpoint/2010/main" val="2476908685"/>
+      </p:ext>
+    </p:extLst>
+  </p:cSld>
+  <p:clrMapOvr>
+    <a:masterClrMapping/>
+  </p:clrMapOvr>
+</p:notes>
+</file>
+
 <file path=ppt/slideLayouts/slideLayout1.xml><?xml version="1.0" encoding="utf-8"?>
 <p:sldLayout xmlns:a="http://schemas.openxmlformats.org/drawingml/2006/main" xmlns:r="http://schemas.openxmlformats.org/officeDocument/2006/relationships" xmlns:p="http://schemas.openxmlformats.org/presentationml/2006/main" type="title" preserve="1">
   <p:cSld name="Title Slide">
@@ -310,7 +746,7 @@
           <a:p>
             <a:fld id="{5BCAD085-E8A6-8845-BD4E-CB4CCA059FC4}" type="datetimeFigureOut">
               <a:rPr lang="en-US" smtClean="0"/>
-              <a:t>5/14/2026</a:t>
+              <a:t>6/11/2026</a:t>
             </a:fld>
             <a:endParaRPr lang="en-US"/>
           </a:p>
@@ -478,7 +914,7 @@
           <a:p>
             <a:fld id="{5BCAD085-E8A6-8845-BD4E-CB4CCA059FC4}" type="datetimeFigureOut">
               <a:rPr lang="en-US" smtClean="0"/>
-              <a:t>5/14/2026</a:t>
+              <a:t>6/11/2026</a:t>
             </a:fld>
             <a:endParaRPr lang="en-US"/>
           </a:p>
@@ -656,7 +1092,7 @@
           <a:p>
             <a:fld id="{5BCAD085-E8A6-8845-BD4E-CB4CCA059FC4}" type="datetimeFigureOut">
               <a:rPr lang="en-US" smtClean="0"/>
-              <a:t>5/14/2026</a:t>
+              <a:t>6/11/2026</a:t>
             </a:fld>
             <a:endParaRPr lang="en-US"/>
           </a:p>
@@ -824,7 +1260,7 @@
           <a:p>
             <a:fld id="{5BCAD085-E8A6-8845-BD4E-CB4CCA059FC4}" type="datetimeFigureOut">
               <a:rPr lang="en-US" smtClean="0"/>
-              <a:t>5/14/2026</a:t>
+              <a:t>6/11/2026</a:t>
             </a:fld>
             <a:endParaRPr lang="en-US"/>
           </a:p>
@@ -1069,7 +1505,7 @@
           <a:p>
             <a:fld id="{5BCAD085-E8A6-8845-BD4E-CB4CCA059FC4}" type="datetimeFigureOut">
               <a:rPr lang="en-US" smtClean="0"/>
-              <a:t>5/14/2026</a:t>
+              <a:t>6/11/2026</a:t>
             </a:fld>
             <a:endParaRPr lang="en-US"/>
           </a:p>
@@ -1354,7 +1790,7 @@
           <a:p>
             <a:fld id="{5BCAD085-E8A6-8845-BD4E-CB4CCA059FC4}" type="datetimeFigureOut">
               <a:rPr lang="en-US" smtClean="0"/>
-              <a:t>5/14/2026</a:t>
+              <a:t>6/11/2026</a:t>
             </a:fld>
             <a:endParaRPr lang="en-US"/>
           </a:p>
@@ -1773,7 +2209,7 @@
           <a:p>
             <a:fld id="{5BCAD085-E8A6-8845-BD4E-CB4CCA059FC4}" type="datetimeFigureOut">
               <a:rPr lang="en-US" smtClean="0"/>
-              <a:t>5/14/2026</a:t>
+              <a:t>6/11/2026</a:t>
             </a:fld>
             <a:endParaRPr lang="en-US"/>
           </a:p>
@@ -1890,7 +2326,7 @@
           <a:p>
             <a:fld id="{5BCAD085-E8A6-8845-BD4E-CB4CCA059FC4}" type="datetimeFigureOut">
               <a:rPr lang="en-US" smtClean="0"/>
-              <a:t>5/14/2026</a:t>
+              <a:t>6/11/2026</a:t>
             </a:fld>
             <a:endParaRPr lang="en-US"/>
           </a:p>
@@ -1985,7 +2421,7 @@
           <a:p>
             <a:fld id="{5BCAD085-E8A6-8845-BD4E-CB4CCA059FC4}" type="datetimeFigureOut">
               <a:rPr lang="en-US" smtClean="0"/>
-              <a:t>5/14/2026</a:t>
+              <a:t>6/11/2026</a:t>
             </a:fld>
             <a:endParaRPr lang="en-US"/>
           </a:p>
@@ -2260,7 +2696,7 @@
           <a:p>
             <a:fld id="{5BCAD085-E8A6-8845-BD4E-CB4CCA059FC4}" type="datetimeFigureOut">
               <a:rPr lang="en-US" smtClean="0"/>
-              <a:t>5/14/2026</a:t>
+              <a:t>6/11/2026</a:t>
             </a:fld>
             <a:endParaRPr lang="en-US"/>
           </a:p>
@@ -2512,7 +2948,7 @@
           <a:p>
             <a:fld id="{5BCAD085-E8A6-8845-BD4E-CB4CCA059FC4}" type="datetimeFigureOut">
               <a:rPr lang="en-US" smtClean="0"/>
-              <a:t>5/14/2026</a:t>
+              <a:t>6/11/2026</a:t>
             </a:fld>
             <a:endParaRPr lang="en-US"/>
           </a:p>
@@ -2723,7 +3159,7 @@
           <a:p>
             <a:fld id="{5BCAD085-E8A6-8845-BD4E-CB4CCA059FC4}" type="datetimeFigureOut">
               <a:rPr lang="en-US" smtClean="0"/>
-              <a:t>5/14/2026</a:t>
+              <a:t>6/11/2026</a:t>
             </a:fld>
             <a:endParaRPr lang="en-US"/>
           </a:p>
@@ -3143,94 +3579,115 @@
           </a:p>
         </p:txBody>
       </p:sp>
-      <p:sp>
-        <p:nvSpPr>
-          <p:cNvPr id="3" name="Oval 2"/>
-          <p:cNvSpPr/>
-          <p:nvPr/>
-        </p:nvSpPr>
-        <p:spPr>
+      <p:grpSp>
+        <p:nvGrpSpPr>
+          <p:cNvPr id="11" name="Gruppieren 10">
+            <a:extLst>
+              <a:ext uri="{FF2B5EF4-FFF2-40B4-BE49-F238E27FC236}">
+                <a16:creationId xmlns:a16="http://schemas.microsoft.com/office/drawing/2014/main" id="{B9905627-FA50-4359-9F60-BC7451BEDC01}"/>
+              </a:ext>
+            </a:extLst>
+          </p:cNvPr>
+          <p:cNvGrpSpPr/>
+          <p:nvPr/>
+        </p:nvGrpSpPr>
+        <p:grpSpPr>
           <a:xfrm>
             <a:off x="7315200" y="-1828800"/>
             <a:ext cx="7772400" cy="7772400"/>
-          </a:xfrm>
-          <a:prstGeom prst="ellipse">
-            <a:avLst/>
-          </a:prstGeom>
-          <a:solidFill>
-            <a:srgbClr val="9D4EDD"/>
-          </a:solidFill>
-          <a:ln>
-            <a:noFill/>
-          </a:ln>
-        </p:spPr>
-        <p:style>
-          <a:lnRef idx="1">
-            <a:schemeClr val="accent1"/>
-          </a:lnRef>
-          <a:fillRef idx="3">
-            <a:schemeClr val="accent1"/>
-          </a:fillRef>
-          <a:effectRef idx="2">
-            <a:schemeClr val="accent1"/>
-          </a:effectRef>
-          <a:fontRef idx="minor">
-            <a:schemeClr val="lt1"/>
-          </a:fontRef>
-        </p:style>
-        <p:txBody>
-          <a:bodyPr rtlCol="0" anchor="ctr"/>
-          <a:lstStyle/>
-          <a:p>
-            <a:pPr algn="ctr"/>
-            <a:endParaRPr/>
-          </a:p>
-        </p:txBody>
-      </p:sp>
-      <p:sp>
-        <p:nvSpPr>
-          <p:cNvPr id="4" name="Oval 3"/>
-          <p:cNvSpPr/>
-          <p:nvPr/>
-        </p:nvSpPr>
-        <p:spPr>
-          <a:xfrm>
-            <a:off x="8686800" y="-914400"/>
-            <a:ext cx="6400800" cy="6400800"/>
-          </a:xfrm>
-          <a:prstGeom prst="ellipse">
-            <a:avLst/>
-          </a:prstGeom>
-          <a:solidFill>
-            <a:srgbClr val="140E29"/>
-          </a:solidFill>
-          <a:ln>
-            <a:noFill/>
-          </a:ln>
-        </p:spPr>
-        <p:style>
-          <a:lnRef idx="1">
-            <a:schemeClr val="accent1"/>
-          </a:lnRef>
-          <a:fillRef idx="3">
-            <a:schemeClr val="accent1"/>
-          </a:fillRef>
-          <a:effectRef idx="2">
-            <a:schemeClr val="accent1"/>
-          </a:effectRef>
-          <a:fontRef idx="minor">
-            <a:schemeClr val="lt1"/>
-          </a:fontRef>
-        </p:style>
-        <p:txBody>
-          <a:bodyPr rtlCol="0" anchor="ctr"/>
-          <a:lstStyle/>
-          <a:p>
-            <a:pPr algn="ctr"/>
-            <a:endParaRPr/>
-          </a:p>
-        </p:txBody>
-      </p:sp>
+            <a:chOff x="7315200" y="-1828800"/>
+            <a:chExt cx="7772400" cy="7772400"/>
+          </a:xfrm>
+        </p:grpSpPr>
+        <p:sp>
+          <p:nvSpPr>
+            <p:cNvPr id="3" name="Oval 2"/>
+            <p:cNvSpPr/>
+            <p:nvPr/>
+          </p:nvSpPr>
+          <p:spPr>
+            <a:xfrm>
+              <a:off x="7315200" y="-1828800"/>
+              <a:ext cx="7772400" cy="7772400"/>
+            </a:xfrm>
+            <a:prstGeom prst="ellipse">
+              <a:avLst/>
+            </a:prstGeom>
+            <a:solidFill>
+              <a:srgbClr val="9D4EDD"/>
+            </a:solidFill>
+            <a:ln>
+              <a:noFill/>
+            </a:ln>
+          </p:spPr>
+          <p:style>
+            <a:lnRef idx="1">
+              <a:schemeClr val="accent1"/>
+            </a:lnRef>
+            <a:fillRef idx="3">
+              <a:schemeClr val="accent1"/>
+            </a:fillRef>
+            <a:effectRef idx="2">
+              <a:schemeClr val="accent1"/>
+            </a:effectRef>
+            <a:fontRef idx="minor">
+              <a:schemeClr val="lt1"/>
+            </a:fontRef>
+          </p:style>
+          <p:txBody>
+            <a:bodyPr rtlCol="0" anchor="ctr"/>
+            <a:lstStyle/>
+            <a:p>
+              <a:pPr algn="ctr"/>
+              <a:endParaRPr/>
+            </a:p>
+          </p:txBody>
+        </p:sp>
+        <p:sp>
+          <p:nvSpPr>
+            <p:cNvPr id="4" name="Oval 3"/>
+            <p:cNvSpPr/>
+            <p:nvPr/>
+          </p:nvSpPr>
+          <p:spPr>
+            <a:xfrm>
+              <a:off x="8686800" y="-914400"/>
+              <a:ext cx="6400800" cy="6400800"/>
+            </a:xfrm>
+            <a:prstGeom prst="ellipse">
+              <a:avLst/>
+            </a:prstGeom>
+            <a:solidFill>
+              <a:srgbClr val="140E29"/>
+            </a:solidFill>
+            <a:ln>
+              <a:noFill/>
+            </a:ln>
+          </p:spPr>
+          <p:style>
+            <a:lnRef idx="1">
+              <a:schemeClr val="accent1"/>
+            </a:lnRef>
+            <a:fillRef idx="3">
+              <a:schemeClr val="accent1"/>
+            </a:fillRef>
+            <a:effectRef idx="2">
+              <a:schemeClr val="accent1"/>
+            </a:effectRef>
+            <a:fontRef idx="minor">
+              <a:schemeClr val="lt1"/>
+            </a:fontRef>
+          </p:style>
+          <p:txBody>
+            <a:bodyPr rtlCol="0" anchor="ctr"/>
+            <a:lstStyle/>
+            <a:p>
+              <a:pPr algn="ctr"/>
+              <a:endParaRPr/>
+            </a:p>
+          </p:txBody>
+        </p:sp>
+      </p:grpSp>
       <p:sp>
         <p:nvSpPr>
           <p:cNvPr id="5" name="Oval 4"/>
@@ -3334,15 +3791,39 @@
           <a:p>
             <a:pPr algn="l"/>
             <a:r>
-              <a:rPr sz="4800" b="1" i="0">
+              <a:rPr sz="4800" b="1" i="0" dirty="0" err="1">
                 <a:solidFill>
                   <a:srgbClr val="FFFFFF"/>
                 </a:solidFill>
                 <a:latin typeface="Calibri"/>
               </a:rPr>
-              <a:t>Konfigurierbare
-Streaming-Landingpage.</a:t>
-            </a:r>
+              <a:t>Konfigurierbare</a:t>
+            </a:r>
+            <a:r>
+              <a:rPr sz="4800" b="1" i="0" dirty="0">
+                <a:solidFill>
+                  <a:srgbClr val="FFFFFF"/>
+                </a:solidFill>
+                <a:latin typeface="Calibri"/>
+              </a:rPr>
+              <a:t>
+Streaming-</a:t>
+            </a:r>
+            <a:r>
+              <a:rPr sz="4800" b="1" i="0" dirty="0" err="1">
+                <a:solidFill>
+                  <a:srgbClr val="FFFFFF"/>
+                </a:solidFill>
+                <a:latin typeface="Calibri"/>
+              </a:rPr>
+              <a:t>Landingpage</a:t>
+            </a:r>
+            <a:endParaRPr sz="4800" b="1" i="0" dirty="0">
+              <a:solidFill>
+                <a:srgbClr val="FFFFFF"/>
+              </a:solidFill>
+              <a:latin typeface="Calibri"/>
+            </a:endParaRPr>
           </a:p>
         </p:txBody>
       </p:sp>
@@ -3448,6 +3929,214 @@
               </a:rPr>
               <a:t>Sommersemester 2026</a:t>
             </a:r>
+          </a:p>
+        </p:txBody>
+      </p:sp>
+      <p:sp>
+        <p:nvSpPr>
+          <p:cNvPr id="12" name="Rounded Rectangle 6">
+            <a:extLst>
+              <a:ext uri="{FF2B5EF4-FFF2-40B4-BE49-F238E27FC236}">
+                <a16:creationId xmlns:a16="http://schemas.microsoft.com/office/drawing/2014/main" id="{CEDD5F35-2163-44A2-A174-D07A6F067E20}"/>
+              </a:ext>
+            </a:extLst>
+          </p:cNvPr>
+          <p:cNvSpPr/>
+          <p:nvPr/>
+        </p:nvSpPr>
+        <p:spPr>
+          <a:xfrm>
+            <a:off x="-11132820" y="2468880"/>
+            <a:ext cx="10881360" cy="868680"/>
+          </a:xfrm>
+          <a:prstGeom prst="roundRect">
+            <a:avLst>
+              <a:gd name="adj" fmla="val 25000"/>
+            </a:avLst>
+          </a:prstGeom>
+          <a:solidFill>
+            <a:srgbClr val="291E52"/>
+          </a:solidFill>
+          <a:ln>
+            <a:noFill/>
+          </a:ln>
+        </p:spPr>
+        <p:style>
+          <a:lnRef idx="1">
+            <a:schemeClr val="accent1"/>
+          </a:lnRef>
+          <a:fillRef idx="3">
+            <a:schemeClr val="accent1"/>
+          </a:fillRef>
+          <a:effectRef idx="2">
+            <a:schemeClr val="accent1"/>
+          </a:effectRef>
+          <a:fontRef idx="minor">
+            <a:schemeClr val="lt1"/>
+          </a:fontRef>
+        </p:style>
+        <p:txBody>
+          <a:bodyPr rtlCol="0" anchor="ctr"/>
+          <a:lstStyle/>
+          <a:p>
+            <a:pPr algn="ctr"/>
+            <a:endParaRPr/>
+          </a:p>
+        </p:txBody>
+      </p:sp>
+      <p:sp>
+        <p:nvSpPr>
+          <p:cNvPr id="13" name="Rounded Rectangle 11">
+            <a:extLst>
+              <a:ext uri="{FF2B5EF4-FFF2-40B4-BE49-F238E27FC236}">
+                <a16:creationId xmlns:a16="http://schemas.microsoft.com/office/drawing/2014/main" id="{476765D3-A6BB-4438-9DD1-02AE0B99E493}"/>
+              </a:ext>
+            </a:extLst>
+          </p:cNvPr>
+          <p:cNvSpPr/>
+          <p:nvPr/>
+        </p:nvSpPr>
+        <p:spPr>
+          <a:xfrm>
+            <a:off x="-11132820" y="3429000"/>
+            <a:ext cx="10881360" cy="868680"/>
+          </a:xfrm>
+          <a:prstGeom prst="roundRect">
+            <a:avLst>
+              <a:gd name="adj" fmla="val 25000"/>
+            </a:avLst>
+          </a:prstGeom>
+          <a:solidFill>
+            <a:srgbClr val="291E52"/>
+          </a:solidFill>
+          <a:ln>
+            <a:noFill/>
+          </a:ln>
+        </p:spPr>
+        <p:style>
+          <a:lnRef idx="1">
+            <a:schemeClr val="accent1"/>
+          </a:lnRef>
+          <a:fillRef idx="3">
+            <a:schemeClr val="accent1"/>
+          </a:fillRef>
+          <a:effectRef idx="2">
+            <a:schemeClr val="accent1"/>
+          </a:effectRef>
+          <a:fontRef idx="minor">
+            <a:schemeClr val="lt1"/>
+          </a:fontRef>
+        </p:style>
+        <p:txBody>
+          <a:bodyPr rtlCol="0" anchor="ctr"/>
+          <a:lstStyle/>
+          <a:p>
+            <a:pPr algn="ctr"/>
+            <a:endParaRPr/>
+          </a:p>
+        </p:txBody>
+      </p:sp>
+      <p:sp>
+        <p:nvSpPr>
+          <p:cNvPr id="14" name="Rounded Rectangle 16">
+            <a:extLst>
+              <a:ext uri="{FF2B5EF4-FFF2-40B4-BE49-F238E27FC236}">
+                <a16:creationId xmlns:a16="http://schemas.microsoft.com/office/drawing/2014/main" id="{403A9588-F9B9-4F51-BECE-E630D3593D8C}"/>
+              </a:ext>
+            </a:extLst>
+          </p:cNvPr>
+          <p:cNvSpPr/>
+          <p:nvPr/>
+        </p:nvSpPr>
+        <p:spPr>
+          <a:xfrm>
+            <a:off x="-11132820" y="4389120"/>
+            <a:ext cx="10881360" cy="868680"/>
+          </a:xfrm>
+          <a:prstGeom prst="roundRect">
+            <a:avLst>
+              <a:gd name="adj" fmla="val 25000"/>
+            </a:avLst>
+          </a:prstGeom>
+          <a:solidFill>
+            <a:srgbClr val="291E52"/>
+          </a:solidFill>
+          <a:ln>
+            <a:noFill/>
+          </a:ln>
+        </p:spPr>
+        <p:style>
+          <a:lnRef idx="1">
+            <a:schemeClr val="accent1"/>
+          </a:lnRef>
+          <a:fillRef idx="3">
+            <a:schemeClr val="accent1"/>
+          </a:fillRef>
+          <a:effectRef idx="2">
+            <a:schemeClr val="accent1"/>
+          </a:effectRef>
+          <a:fontRef idx="minor">
+            <a:schemeClr val="lt1"/>
+          </a:fontRef>
+        </p:style>
+        <p:txBody>
+          <a:bodyPr rtlCol="0" anchor="ctr"/>
+          <a:lstStyle/>
+          <a:p>
+            <a:pPr algn="ctr"/>
+            <a:endParaRPr/>
+          </a:p>
+        </p:txBody>
+      </p:sp>
+      <p:sp>
+        <p:nvSpPr>
+          <p:cNvPr id="15" name="Rounded Rectangle 21">
+            <a:extLst>
+              <a:ext uri="{FF2B5EF4-FFF2-40B4-BE49-F238E27FC236}">
+                <a16:creationId xmlns:a16="http://schemas.microsoft.com/office/drawing/2014/main" id="{7240DCD3-ED70-421A-95B2-438B449C4DB9}"/>
+              </a:ext>
+            </a:extLst>
+          </p:cNvPr>
+          <p:cNvSpPr/>
+          <p:nvPr/>
+        </p:nvSpPr>
+        <p:spPr>
+          <a:xfrm>
+            <a:off x="-11132820" y="5349240"/>
+            <a:ext cx="10881360" cy="868680"/>
+          </a:xfrm>
+          <a:prstGeom prst="roundRect">
+            <a:avLst>
+              <a:gd name="adj" fmla="val 25000"/>
+            </a:avLst>
+          </a:prstGeom>
+          <a:solidFill>
+            <a:srgbClr val="291E52"/>
+          </a:solidFill>
+          <a:ln>
+            <a:noFill/>
+          </a:ln>
+        </p:spPr>
+        <p:style>
+          <a:lnRef idx="1">
+            <a:schemeClr val="accent1"/>
+          </a:lnRef>
+          <a:fillRef idx="3">
+            <a:schemeClr val="accent1"/>
+          </a:fillRef>
+          <a:effectRef idx="2">
+            <a:schemeClr val="accent1"/>
+          </a:effectRef>
+          <a:fontRef idx="minor">
+            <a:schemeClr val="lt1"/>
+          </a:fontRef>
+        </p:style>
+        <p:txBody>
+          <a:bodyPr rtlCol="0" anchor="ctr"/>
+          <a:lstStyle/>
+          <a:p>
+            <a:pPr algn="ctr"/>
+            <a:endParaRPr/>
           </a:p>
         </p:txBody>
       </p:sp>
@@ -3456,6 +4145,18 @@
   <p:clrMapOvr>
     <a:masterClrMapping/>
   </p:clrMapOvr>
+  <mc:AlternateContent xmlns:mc="http://schemas.openxmlformats.org/markup-compatibility/2006" xmlns:p159="http://schemas.microsoft.com/office/powerpoint/2015/09/main">
+    <mc:Choice Requires="p159">
+      <p:transition xmlns:p14="http://schemas.microsoft.com/office/powerpoint/2010/main" spd="slow" p14:dur="2000">
+        <p159:morph option="byObject"/>
+      </p:transition>
+    </mc:Choice>
+    <mc:Fallback xmlns="">
+      <p:transition spd="slow">
+        <p:fade/>
+      </p:transition>
+    </mc:Fallback>
+  </mc:AlternateContent>
 </p:sld>
 </file>
 
@@ -3484,7 +4185,7 @@
         </p:nvSpPr>
         <p:spPr>
           <a:xfrm>
-            <a:off x="0" y="0"/>
+            <a:off x="-15088" y="0"/>
             <a:ext cx="12191695" cy="6858000"/>
           </a:xfrm>
           <a:prstGeom prst="rect">
@@ -3609,7 +4310,7 @@
         <p:spPr>
           <a:xfrm>
             <a:off x="640080" y="914400"/>
-            <a:ext cx="9144000" cy="1280160"/>
+            <a:ext cx="9144000" cy="677108"/>
           </a:xfrm>
           <a:prstGeom prst="rect">
             <a:avLst/>
@@ -3624,48 +4325,13 @@
           <a:p>
             <a:pPr algn="l"/>
             <a:r>
-              <a:rPr sz="4400" b="1" i="0">
+              <a:rPr sz="4400" b="1" i="0" dirty="0">
                 <a:solidFill>
                   <a:srgbClr val="FFFFFF"/>
                 </a:solidFill>
                 <a:latin typeface="Calibri"/>
               </a:rPr>
-              <a:t>Agenda.</a:t>
-            </a:r>
-          </a:p>
-        </p:txBody>
-      </p:sp>
-      <p:sp>
-        <p:nvSpPr>
-          <p:cNvPr id="6" name="TextBox 5"/>
-          <p:cNvSpPr txBox="1"/>
-          <p:nvPr/>
-        </p:nvSpPr>
-        <p:spPr>
-          <a:xfrm>
-            <a:off x="640080" y="1783080"/>
-            <a:ext cx="10058400" cy="457200"/>
-          </a:xfrm>
-          <a:prstGeom prst="rect">
-            <a:avLst/>
-          </a:prstGeom>
-          <a:noFill/>
-        </p:spPr>
-        <p:txBody>
-          <a:bodyPr wrap="square" lIns="0" tIns="0" rIns="0" bIns="0" anchor="t">
-            <a:spAutoFit/>
-          </a:bodyPr>
-          <a:lstStyle/>
-          <a:p>
-            <a:pPr algn="l"/>
-            <a:r>
-              <a:rPr sz="1600" b="0" i="1">
-                <a:solidFill>
-                  <a:srgbClr val="C77DFF"/>
-                </a:solidFill>
-                <a:latin typeface="Calibri"/>
-              </a:rPr>
-              <a:t>Vier Punkte. Zehn Minuten. Sechs davon Live-Demo.</a:t>
+              <a:t>Agenda</a:t>
             </a:r>
           </a:p>
         </p:txBody>
@@ -3823,41 +4489,6 @@
       </p:sp>
       <p:sp>
         <p:nvSpPr>
-          <p:cNvPr id="11" name="TextBox 10"/>
-          <p:cNvSpPr txBox="1"/>
-          <p:nvPr/>
-        </p:nvSpPr>
-        <p:spPr>
-          <a:xfrm>
-            <a:off x="9692640" y="2724912"/>
-            <a:ext cx="1828800" cy="411480"/>
-          </a:xfrm>
-          <a:prstGeom prst="rect">
-            <a:avLst/>
-          </a:prstGeom>
-          <a:noFill/>
-        </p:spPr>
-        <p:txBody>
-          <a:bodyPr wrap="square" lIns="0" tIns="0" rIns="0" bIns="0" anchor="t">
-            <a:spAutoFit/>
-          </a:bodyPr>
-          <a:lstStyle/>
-          <a:p>
-            <a:pPr algn="r"/>
-            <a:r>
-              <a:rPr sz="1400" b="1" i="0">
-                <a:solidFill>
-                  <a:srgbClr val="C77DFF"/>
-                </a:solidFill>
-                <a:latin typeface="Calibri"/>
-              </a:rPr>
-              <a:t>≈ 2 min</a:t>
-            </a:r>
-          </a:p>
-        </p:txBody>
-      </p:sp>
-      <p:sp>
-        <p:nvSpPr>
           <p:cNvPr id="12" name="Rounded Rectangle 11"/>
           <p:cNvSpPr/>
           <p:nvPr/>
@@ -4009,41 +4640,6 @@
       </p:sp>
       <p:sp>
         <p:nvSpPr>
-          <p:cNvPr id="16" name="TextBox 15"/>
-          <p:cNvSpPr txBox="1"/>
-          <p:nvPr/>
-        </p:nvSpPr>
-        <p:spPr>
-          <a:xfrm>
-            <a:off x="9692640" y="3685032"/>
-            <a:ext cx="1828800" cy="411480"/>
-          </a:xfrm>
-          <a:prstGeom prst="rect">
-            <a:avLst/>
-          </a:prstGeom>
-          <a:noFill/>
-        </p:spPr>
-        <p:txBody>
-          <a:bodyPr wrap="square" lIns="0" tIns="0" rIns="0" bIns="0" anchor="t">
-            <a:spAutoFit/>
-          </a:bodyPr>
-          <a:lstStyle/>
-          <a:p>
-            <a:pPr algn="r"/>
-            <a:r>
-              <a:rPr sz="1400" b="1" i="0">
-                <a:solidFill>
-                  <a:srgbClr val="C77DFF"/>
-                </a:solidFill>
-                <a:latin typeface="Calibri"/>
-              </a:rPr>
-              <a:t>≈ 1 min</a:t>
-            </a:r>
-          </a:p>
-        </p:txBody>
-      </p:sp>
-      <p:sp>
-        <p:nvSpPr>
           <p:cNvPr id="17" name="Rounded Rectangle 16"/>
           <p:cNvSpPr/>
           <p:nvPr/>
@@ -4195,41 +4791,6 @@
       </p:sp>
       <p:sp>
         <p:nvSpPr>
-          <p:cNvPr id="21" name="TextBox 20"/>
-          <p:cNvSpPr txBox="1"/>
-          <p:nvPr/>
-        </p:nvSpPr>
-        <p:spPr>
-          <a:xfrm>
-            <a:off x="9692640" y="4645152"/>
-            <a:ext cx="1828800" cy="411480"/>
-          </a:xfrm>
-          <a:prstGeom prst="rect">
-            <a:avLst/>
-          </a:prstGeom>
-          <a:noFill/>
-        </p:spPr>
-        <p:txBody>
-          <a:bodyPr wrap="square" lIns="0" tIns="0" rIns="0" bIns="0" anchor="t">
-            <a:spAutoFit/>
-          </a:bodyPr>
-          <a:lstStyle/>
-          <a:p>
-            <a:pPr algn="r"/>
-            <a:r>
-              <a:rPr sz="1400" b="1" i="0">
-                <a:solidFill>
-                  <a:srgbClr val="C77DFF"/>
-                </a:solidFill>
-                <a:latin typeface="Calibri"/>
-              </a:rPr>
-              <a:t>≈ 6 min</a:t>
-            </a:r>
-          </a:p>
-        </p:txBody>
-      </p:sp>
-      <p:sp>
-        <p:nvSpPr>
           <p:cNvPr id="22" name="Rounded Rectangle 21"/>
           <p:cNvSpPr/>
           <p:nvPr/>
@@ -4381,14 +4942,14 @@
       </p:sp>
       <p:sp>
         <p:nvSpPr>
-          <p:cNvPr id="26" name="TextBox 25"/>
+          <p:cNvPr id="27" name="TextBox 26"/>
           <p:cNvSpPr txBox="1"/>
           <p:nvPr/>
         </p:nvSpPr>
         <p:spPr>
           <a:xfrm>
-            <a:off x="9692640" y="5605272"/>
-            <a:ext cx="1828800" cy="411480"/>
+            <a:off x="11338560" y="6446520"/>
+            <a:ext cx="731520" cy="274320"/>
           </a:xfrm>
           <a:prstGeom prst="rect">
             <a:avLst/>
@@ -4403,41 +4964,6 @@
           <a:p>
             <a:pPr algn="r"/>
             <a:r>
-              <a:rPr sz="1400" b="1" i="0">
-                <a:solidFill>
-                  <a:srgbClr val="C77DFF"/>
-                </a:solidFill>
-                <a:latin typeface="Calibri"/>
-              </a:rPr>
-              <a:t>≈ 1 min</a:t>
-            </a:r>
-          </a:p>
-        </p:txBody>
-      </p:sp>
-      <p:sp>
-        <p:nvSpPr>
-          <p:cNvPr id="27" name="TextBox 26"/>
-          <p:cNvSpPr txBox="1"/>
-          <p:nvPr/>
-        </p:nvSpPr>
-        <p:spPr>
-          <a:xfrm>
-            <a:off x="11338560" y="6446520"/>
-            <a:ext cx="731520" cy="274320"/>
-          </a:xfrm>
-          <a:prstGeom prst="rect">
-            <a:avLst/>
-          </a:prstGeom>
-          <a:noFill/>
-        </p:spPr>
-        <p:txBody>
-          <a:bodyPr wrap="square" lIns="0" tIns="0" rIns="0" bIns="0" anchor="t">
-            <a:spAutoFit/>
-          </a:bodyPr>
-          <a:lstStyle/>
-          <a:p>
-            <a:pPr algn="r"/>
-            <a:r>
               <a:rPr sz="1000" b="0" i="0">
                 <a:solidFill>
                   <a:srgbClr val="B6A8D3"/>
@@ -4449,11 +4975,144 @@
           </a:p>
         </p:txBody>
       </p:sp>
+      <p:grpSp>
+        <p:nvGrpSpPr>
+          <p:cNvPr id="29" name="Gruppieren 28">
+            <a:extLst>
+              <a:ext uri="{FF2B5EF4-FFF2-40B4-BE49-F238E27FC236}">
+                <a16:creationId xmlns:a16="http://schemas.microsoft.com/office/drawing/2014/main" id="{17876F8D-8149-4A75-A471-B1C5494BE397}"/>
+              </a:ext>
+            </a:extLst>
+          </p:cNvPr>
+          <p:cNvGrpSpPr/>
+          <p:nvPr/>
+        </p:nvGrpSpPr>
+        <p:grpSpPr>
+          <a:xfrm>
+            <a:off x="12091035" y="-5960745"/>
+            <a:ext cx="7772400" cy="7772400"/>
+            <a:chOff x="7315200" y="-1828800"/>
+            <a:chExt cx="7772400" cy="7772400"/>
+          </a:xfrm>
+        </p:grpSpPr>
+        <p:sp>
+          <p:nvSpPr>
+            <p:cNvPr id="30" name="Oval 2">
+              <a:extLst>
+                <a:ext uri="{FF2B5EF4-FFF2-40B4-BE49-F238E27FC236}">
+                  <a16:creationId xmlns:a16="http://schemas.microsoft.com/office/drawing/2014/main" id="{1778DFA8-0C78-4807-929A-166D357E9952}"/>
+                </a:ext>
+              </a:extLst>
+            </p:cNvPr>
+            <p:cNvSpPr/>
+            <p:nvPr/>
+          </p:nvSpPr>
+          <p:spPr>
+            <a:xfrm>
+              <a:off x="7315200" y="-1828800"/>
+              <a:ext cx="7772400" cy="7772400"/>
+            </a:xfrm>
+            <a:prstGeom prst="ellipse">
+              <a:avLst/>
+            </a:prstGeom>
+            <a:solidFill>
+              <a:srgbClr val="9D4EDD"/>
+            </a:solidFill>
+            <a:ln>
+              <a:noFill/>
+            </a:ln>
+          </p:spPr>
+          <p:style>
+            <a:lnRef idx="1">
+              <a:schemeClr val="accent1"/>
+            </a:lnRef>
+            <a:fillRef idx="3">
+              <a:schemeClr val="accent1"/>
+            </a:fillRef>
+            <a:effectRef idx="2">
+              <a:schemeClr val="accent1"/>
+            </a:effectRef>
+            <a:fontRef idx="minor">
+              <a:schemeClr val="lt1"/>
+            </a:fontRef>
+          </p:style>
+          <p:txBody>
+            <a:bodyPr rtlCol="0" anchor="ctr"/>
+            <a:lstStyle/>
+            <a:p>
+              <a:pPr algn="ctr"/>
+              <a:endParaRPr/>
+            </a:p>
+          </p:txBody>
+        </p:sp>
+        <p:sp>
+          <p:nvSpPr>
+            <p:cNvPr id="31" name="Oval 3">
+              <a:extLst>
+                <a:ext uri="{FF2B5EF4-FFF2-40B4-BE49-F238E27FC236}">
+                  <a16:creationId xmlns:a16="http://schemas.microsoft.com/office/drawing/2014/main" id="{A8C75B3B-F411-4A58-BB5D-BED92781E19D}"/>
+                </a:ext>
+              </a:extLst>
+            </p:cNvPr>
+            <p:cNvSpPr/>
+            <p:nvPr/>
+          </p:nvSpPr>
+          <p:spPr>
+            <a:xfrm>
+              <a:off x="8686800" y="-914400"/>
+              <a:ext cx="6400800" cy="6400800"/>
+            </a:xfrm>
+            <a:prstGeom prst="ellipse">
+              <a:avLst/>
+            </a:prstGeom>
+            <a:solidFill>
+              <a:srgbClr val="140E29"/>
+            </a:solidFill>
+            <a:ln>
+              <a:noFill/>
+            </a:ln>
+          </p:spPr>
+          <p:style>
+            <a:lnRef idx="1">
+              <a:schemeClr val="accent1"/>
+            </a:lnRef>
+            <a:fillRef idx="3">
+              <a:schemeClr val="accent1"/>
+            </a:fillRef>
+            <a:effectRef idx="2">
+              <a:schemeClr val="accent1"/>
+            </a:effectRef>
+            <a:fontRef idx="minor">
+              <a:schemeClr val="lt1"/>
+            </a:fontRef>
+          </p:style>
+          <p:txBody>
+            <a:bodyPr rtlCol="0" anchor="ctr"/>
+            <a:lstStyle/>
+            <a:p>
+              <a:pPr algn="ctr"/>
+              <a:endParaRPr/>
+            </a:p>
+          </p:txBody>
+        </p:sp>
+      </p:grpSp>
     </p:spTree>
   </p:cSld>
   <p:clrMapOvr>
     <a:masterClrMapping/>
   </p:clrMapOvr>
+  <mc:AlternateContent xmlns:mc="http://schemas.openxmlformats.org/markup-compatibility/2006" xmlns:p159="http://schemas.microsoft.com/office/powerpoint/2015/09/main">
+    <mc:Choice Requires="p159">
+      <p:transition xmlns:p14="http://schemas.microsoft.com/office/powerpoint/2010/main" spd="slow" p14:dur="2000">
+        <p159:morph option="byObject"/>
+      </p:transition>
+    </mc:Choice>
+    <mc:Fallback xmlns="">
+      <p:transition spd="slow">
+        <p:fade/>
+      </p:transition>
+    </mc:Fallback>
+  </mc:AlternateContent>
 </p:sld>
 </file>
 
@@ -4607,7 +5266,7 @@
         <p:spPr>
           <a:xfrm>
             <a:off x="640080" y="914400"/>
-            <a:ext cx="10058400" cy="914400"/>
+            <a:ext cx="10058400" cy="615553"/>
           </a:xfrm>
           <a:prstGeom prst="rect">
             <a:avLst/>
@@ -4622,14 +5281,56 @@
           <a:p>
             <a:pPr algn="l"/>
             <a:r>
-              <a:rPr sz="4000" b="1" i="0">
+              <a:rPr sz="4000" b="1" i="0" dirty="0" err="1">
                 <a:solidFill>
                   <a:srgbClr val="FFFFFF"/>
                 </a:solidFill>
                 <a:latin typeface="Calibri"/>
               </a:rPr>
-              <a:t>Drei wiederkehrende Lücken.</a:t>
-            </a:r>
+              <a:t>Drei</a:t>
+            </a:r>
+            <a:r>
+              <a:rPr sz="4000" b="1" i="0" dirty="0">
+                <a:solidFill>
+                  <a:srgbClr val="FFFFFF"/>
+                </a:solidFill>
+                <a:latin typeface="Calibri"/>
+              </a:rPr>
+              <a:t> </a:t>
+            </a:r>
+            <a:r>
+              <a:rPr sz="4000" b="1" i="0" dirty="0" err="1">
+                <a:solidFill>
+                  <a:srgbClr val="FFFFFF"/>
+                </a:solidFill>
+                <a:latin typeface="Calibri"/>
+              </a:rPr>
+              <a:t>wiederkehrende</a:t>
+            </a:r>
+            <a:r>
+              <a:rPr sz="4000" b="1" i="0" dirty="0">
+                <a:solidFill>
+                  <a:srgbClr val="FFFFFF"/>
+                </a:solidFill>
+                <a:latin typeface="Calibri"/>
+              </a:rPr>
+              <a:t> </a:t>
+            </a:r>
+            <a:r>
+              <a:rPr sz="4000" b="1" i="0" dirty="0" err="1">
+                <a:solidFill>
+                  <a:srgbClr val="FFFFFF"/>
+                </a:solidFill>
+                <a:latin typeface="Calibri"/>
+              </a:rPr>
+              <a:t>Lücken</a:t>
+            </a:r>
+            <a:endParaRPr sz="4000" b="1" i="0" dirty="0">
+              <a:solidFill>
+                <a:srgbClr val="FFFFFF"/>
+              </a:solidFill>
+              <a:latin typeface="Calibri"/>
+            </a:endParaRPr>
           </a:p>
         </p:txBody>
       </p:sp>
@@ -5331,6 +6032,18 @@
   <p:clrMapOvr>
     <a:masterClrMapping/>
   </p:clrMapOvr>
+  <mc:AlternateContent xmlns:mc="http://schemas.openxmlformats.org/markup-compatibility/2006" xmlns:p159="http://schemas.microsoft.com/office/powerpoint/2015/09/main">
+    <mc:Choice Requires="p159">
+      <p:transition xmlns:p14="http://schemas.microsoft.com/office/powerpoint/2010/main" spd="slow" p14:dur="2000">
+        <p159:morph option="byObject"/>
+      </p:transition>
+    </mc:Choice>
+    <mc:Fallback xmlns="">
+      <p:transition spd="slow">
+        <p:fade/>
+      </p:transition>
+    </mc:Fallback>
+  </mc:AlternateContent>
 </p:sld>
 </file>
 
@@ -5366,7 +6079,7 @@
             <a:avLst/>
           </a:prstGeom>
           <a:solidFill>
-            <a:srgbClr val="140E29"/>
+            <a:srgbClr val="1F163A"/>
           </a:solidFill>
           <a:ln>
             <a:noFill/>
@@ -5484,7 +6197,7 @@
         <p:spPr>
           <a:xfrm>
             <a:off x="640080" y="914400"/>
-            <a:ext cx="10058400" cy="914400"/>
+            <a:ext cx="10058400" cy="615553"/>
           </a:xfrm>
           <a:prstGeom prst="rect">
             <a:avLst/>
@@ -5499,13 +6212,40 @@
           <a:p>
             <a:pPr algn="l"/>
             <a:r>
-              <a:rPr sz="4000" b="1" i="0">
+              <a:rPr sz="4000" b="1" i="0" dirty="0" err="1">
                 <a:solidFill>
                   <a:srgbClr val="FFFFFF"/>
                 </a:solidFill>
                 <a:latin typeface="Calibri"/>
               </a:rPr>
-              <a:t>Konfiguration statt Code.</a:t>
+              <a:t>Konfiguration</a:t>
+            </a:r>
+            <a:r>
+              <a:rPr sz="4000" b="1" i="0" dirty="0">
+                <a:solidFill>
+                  <a:srgbClr val="FFFFFF"/>
+                </a:solidFill>
+                <a:latin typeface="Calibri"/>
+              </a:rPr>
+              <a:t> </a:t>
+            </a:r>
+            <a:r>
+              <a:rPr sz="4000" b="1" i="0" dirty="0" err="1">
+                <a:solidFill>
+                  <a:srgbClr val="FFFFFF"/>
+                </a:solidFill>
+                <a:latin typeface="Calibri"/>
+              </a:rPr>
+              <a:t>statt</a:t>
+            </a:r>
+            <a:r>
+              <a:rPr sz="4000" b="1" i="0" dirty="0">
+                <a:solidFill>
+                  <a:srgbClr val="FFFFFF"/>
+                </a:solidFill>
+                <a:latin typeface="Calibri"/>
+              </a:rPr>
+              <a:t> Code</a:t>
             </a:r>
           </a:p>
         </p:txBody>
@@ -5519,7 +6259,7 @@
         <p:spPr>
           <a:xfrm>
             <a:off x="640080" y="1783080"/>
-            <a:ext cx="10058400" cy="457200"/>
+            <a:ext cx="10058400" cy="246221"/>
           </a:xfrm>
           <a:prstGeom prst="rect">
             <a:avLst/>
@@ -5534,13 +6274,103 @@
           <a:p>
             <a:pPr algn="l"/>
             <a:r>
-              <a:rPr sz="1600" b="0" i="1">
+              <a:rPr sz="1600" b="0" i="1" dirty="0">
                 <a:solidFill>
                   <a:srgbClr val="C77DFF"/>
                 </a:solidFill>
                 <a:latin typeface="Calibri"/>
               </a:rPr>
-              <a:t>Live für hd1920x1080 — übertragbar auf beliebige andere Streamer.</a:t>
+              <a:t>Live </a:t>
+            </a:r>
+            <a:r>
+              <a:rPr sz="1600" b="0" i="1" dirty="0" err="1">
+                <a:solidFill>
+                  <a:srgbClr val="C77DFF"/>
+                </a:solidFill>
+                <a:latin typeface="Calibri"/>
+              </a:rPr>
+              <a:t>für</a:t>
+            </a:r>
+            <a:r>
+              <a:rPr sz="1600" b="0" i="1" dirty="0">
+                <a:solidFill>
+                  <a:srgbClr val="C77DFF"/>
+                </a:solidFill>
+                <a:latin typeface="Calibri"/>
+              </a:rPr>
+              <a:t> </a:t>
+            </a:r>
+            <a:r>
+              <a:rPr lang="de-DE" sz="1600" b="0" i="1" dirty="0">
+                <a:solidFill>
+                  <a:srgbClr val="C77DFF"/>
+                </a:solidFill>
+                <a:latin typeface="Calibri"/>
+              </a:rPr>
+              <a:t> einen Kanal</a:t>
+            </a:r>
+            <a:r>
+              <a:rPr sz="1600" b="0" i="1" dirty="0">
+                <a:solidFill>
+                  <a:srgbClr val="C77DFF"/>
+                </a:solidFill>
+                <a:latin typeface="Calibri"/>
+              </a:rPr>
+              <a:t> — </a:t>
+            </a:r>
+            <a:r>
+              <a:rPr sz="1600" b="0" i="1" dirty="0" err="1">
+                <a:solidFill>
+                  <a:srgbClr val="C77DFF"/>
+                </a:solidFill>
+                <a:latin typeface="Calibri"/>
+              </a:rPr>
+              <a:t>übertragbar</a:t>
+            </a:r>
+            <a:r>
+              <a:rPr sz="1600" b="0" i="1" dirty="0">
+                <a:solidFill>
+                  <a:srgbClr val="C77DFF"/>
+                </a:solidFill>
+                <a:latin typeface="Calibri"/>
+              </a:rPr>
+              <a:t> auf </a:t>
+            </a:r>
+            <a:r>
+              <a:rPr sz="1600" b="0" i="1" dirty="0" err="1">
+                <a:solidFill>
+                  <a:srgbClr val="C77DFF"/>
+                </a:solidFill>
+                <a:latin typeface="Calibri"/>
+              </a:rPr>
+              <a:t>beliebige</a:t>
+            </a:r>
+            <a:r>
+              <a:rPr sz="1600" b="0" i="1" dirty="0">
+                <a:solidFill>
+                  <a:srgbClr val="C77DFF"/>
+                </a:solidFill>
+                <a:latin typeface="Calibri"/>
+              </a:rPr>
+              <a:t> </a:t>
+            </a:r>
+            <a:r>
+              <a:rPr sz="1600" b="0" i="1" dirty="0" err="1">
+                <a:solidFill>
+                  <a:srgbClr val="C77DFF"/>
+                </a:solidFill>
+                <a:latin typeface="Calibri"/>
+              </a:rPr>
+              <a:t>andere</a:t>
+            </a:r>
+            <a:r>
+              <a:rPr sz="1600" b="0" i="1" dirty="0">
+                <a:solidFill>
+                  <a:srgbClr val="C77DFF"/>
+                </a:solidFill>
+                <a:latin typeface="Calibri"/>
+              </a:rPr>
+              <a:t> Streamer.</a:t>
             </a:r>
           </a:p>
         </p:txBody>
@@ -6170,6 +7000,18 @@
   <p:clrMapOvr>
     <a:masterClrMapping/>
   </p:clrMapOvr>
+  <mc:AlternateContent xmlns:mc="http://schemas.openxmlformats.org/markup-compatibility/2006" xmlns:p159="http://schemas.microsoft.com/office/powerpoint/2015/09/main">
+    <mc:Choice Requires="p159">
+      <p:transition xmlns:p14="http://schemas.microsoft.com/office/powerpoint/2010/main" spd="slow" p14:dur="2000">
+        <p159:morph option="byObject"/>
+      </p:transition>
+    </mc:Choice>
+    <mc:Fallback xmlns="">
+      <p:transition spd="slow">
+        <p:fade/>
+      </p:transition>
+    </mc:Fallback>
+  </mc:AlternateContent>
 </p:sld>
 </file>
 
@@ -6323,7 +7165,7 @@
         <p:spPr>
           <a:xfrm>
             <a:off x="640080" y="914400"/>
-            <a:ext cx="10058400" cy="914400"/>
+            <a:ext cx="10058400" cy="615553"/>
           </a:xfrm>
           <a:prstGeom prst="rect">
             <a:avLst/>
@@ -6338,13 +7180,22 @@
           <a:p>
             <a:pPr algn="l"/>
             <a:r>
-              <a:rPr sz="4000" b="1" i="0">
+              <a:rPr sz="4000" b="1" i="0" dirty="0" err="1">
                 <a:solidFill>
                   <a:srgbClr val="FFFFFF"/>
                 </a:solidFill>
                 <a:latin typeface="Calibri"/>
               </a:rPr>
-              <a:t>Technologie-Stack.</a:t>
+              <a:t>Technologie</a:t>
+            </a:r>
+            <a:r>
+              <a:rPr sz="4000" b="1" i="0" dirty="0">
+                <a:solidFill>
+                  <a:srgbClr val="FFFFFF"/>
+                </a:solidFill>
+                <a:latin typeface="Calibri"/>
+              </a:rPr>
+              <a:t>-Stack</a:t>
             </a:r>
           </a:p>
         </p:txBody>
@@ -7139,7 +7990,7 @@
         <p:spPr>
           <a:xfrm>
             <a:off x="7360920" y="3776472"/>
-            <a:ext cx="4114800" cy="457200"/>
+            <a:ext cx="4114800" cy="276999"/>
           </a:xfrm>
           <a:prstGeom prst="rect">
             <a:avLst/>
@@ -7154,7 +8005,7 @@
           <a:p>
             <a:pPr algn="l"/>
             <a:r>
-              <a:rPr sz="1800" b="1" i="0">
+              <a:rPr sz="1800" b="1" i="0" dirty="0">
                 <a:solidFill>
                   <a:srgbClr val="FFFFFF"/>
                 </a:solidFill>
@@ -7162,6 +8013,21 @@
               </a:rPr>
               <a:t>Bun</a:t>
             </a:r>
+            <a:r>
+              <a:rPr lang="de-DE" sz="1800" b="1" i="0" dirty="0">
+                <a:solidFill>
+                  <a:srgbClr val="FFFFFF"/>
+                </a:solidFill>
+                <a:latin typeface="Calibri"/>
+              </a:rPr>
+              <a:t> lokal</a:t>
+            </a:r>
+            <a:endParaRPr sz="1800" b="1" i="0" dirty="0">
+              <a:solidFill>
+                <a:srgbClr val="FFFFFF"/>
+              </a:solidFill>
+              <a:latin typeface="Calibri"/>
+            </a:endParaRPr>
           </a:p>
         </p:txBody>
       </p:sp>
@@ -7630,6 +8496,18 @@
   <p:clrMapOvr>
     <a:masterClrMapping/>
   </p:clrMapOvr>
+  <mc:AlternateContent xmlns:mc="http://schemas.openxmlformats.org/markup-compatibility/2006" xmlns:p159="http://schemas.microsoft.com/office/powerpoint/2015/09/main">
+    <mc:Choice Requires="p159">
+      <p:transition xmlns:p14="http://schemas.microsoft.com/office/powerpoint/2010/main" spd="slow" p14:dur="2000">
+        <p159:morph option="byObject"/>
+      </p:transition>
+    </mc:Choice>
+    <mc:Fallback xmlns="">
+      <p:transition spd="slow">
+        <p:fade/>
+      </p:transition>
+    </mc:Fallback>
+  </mc:AlternateContent>
 </p:sld>
 </file>
 
@@ -7658,14 +8536,14 @@
         </p:nvSpPr>
         <p:spPr>
           <a:xfrm>
-            <a:off x="0" y="0"/>
-            <a:ext cx="12191695" cy="6858000"/>
+            <a:off x="305" y="0"/>
+            <a:ext cx="12191695" cy="6995160"/>
           </a:xfrm>
           <a:prstGeom prst="rect">
             <a:avLst/>
           </a:prstGeom>
           <a:solidFill>
-            <a:srgbClr val="FFFFFF"/>
+            <a:srgbClr val="1F163A"/>
           </a:solidFill>
           <a:ln>
             <a:noFill/>
@@ -7697,50 +8575,6 @@
       </p:sp>
       <p:sp>
         <p:nvSpPr>
-          <p:cNvPr id="3" name="Rectangle 2"/>
-          <p:cNvSpPr/>
-          <p:nvPr/>
-        </p:nvSpPr>
-        <p:spPr>
-          <a:xfrm>
-            <a:off x="0" y="0"/>
-            <a:ext cx="12191695" cy="822960"/>
-          </a:xfrm>
-          <a:prstGeom prst="rect">
-            <a:avLst/>
-          </a:prstGeom>
-          <a:solidFill>
-            <a:srgbClr val="140E29"/>
-          </a:solidFill>
-          <a:ln>
-            <a:noFill/>
-          </a:ln>
-        </p:spPr>
-        <p:style>
-          <a:lnRef idx="1">
-            <a:schemeClr val="accent1"/>
-          </a:lnRef>
-          <a:fillRef idx="3">
-            <a:schemeClr val="accent1"/>
-          </a:fillRef>
-          <a:effectRef idx="2">
-            <a:schemeClr val="accent1"/>
-          </a:effectRef>
-          <a:fontRef idx="minor">
-            <a:schemeClr val="lt1"/>
-          </a:fontRef>
-        </p:style>
-        <p:txBody>
-          <a:bodyPr rtlCol="0" anchor="ctr"/>
-          <a:lstStyle/>
-          <a:p>
-            <a:pPr algn="ctr"/>
-            <a:endParaRPr/>
-          </a:p>
-        </p:txBody>
-      </p:sp>
-      <p:sp>
-        <p:nvSpPr>
           <p:cNvPr id="4" name="TextBox 3"/>
           <p:cNvSpPr txBox="1"/>
           <p:nvPr/>
@@ -7809,30 +8643,6 @@
           </a:p>
         </p:txBody>
       </p:sp>
-      <p:pic>
-        <p:nvPicPr>
-          <p:cNvPr id="6" name="Picture 5" descr="uml_components.png"/>
-          <p:cNvPicPr>
-            <a:picLocks noChangeAspect="1"/>
-          </p:cNvPicPr>
-          <p:nvPr/>
-        </p:nvPicPr>
-        <p:blipFill>
-          <a:blip r:embed="rId2"/>
-          <a:stretch>
-            <a:fillRect/>
-          </a:stretch>
-        </p:blipFill>
-        <p:spPr>
-          <a:xfrm>
-            <a:off x="3152016" y="960120"/>
-            <a:ext cx="5887663" cy="5394960"/>
-          </a:xfrm>
-          <a:prstGeom prst="rect">
-            <a:avLst/>
-          </a:prstGeom>
-        </p:spPr>
-      </p:pic>
       <p:sp>
         <p:nvSpPr>
           <p:cNvPr id="7" name="TextBox 6"/>
@@ -7859,7 +8669,7 @@
             <a:r>
               <a:rPr sz="1100" b="0" i="1" dirty="0">
                 <a:solidFill>
-                  <a:srgbClr val="554B6E"/>
+                  <a:srgbClr val="C77DFF"/>
                 </a:solidFill>
                 <a:latin typeface="Calibri"/>
               </a:rPr>
@@ -7868,7 +8678,7 @@
             <a:r>
               <a:rPr sz="1100" b="0" i="1" dirty="0" err="1">
                 <a:solidFill>
-                  <a:srgbClr val="554B6E"/>
+                  <a:srgbClr val="C77DFF"/>
                 </a:solidFill>
                 <a:latin typeface="Calibri"/>
               </a:rPr>
@@ -7877,7 +8687,7 @@
             <a:r>
               <a:rPr sz="1100" b="0" i="1" dirty="0">
                 <a:solidFill>
-                  <a:srgbClr val="554B6E"/>
+                  <a:srgbClr val="C77DFF"/>
                 </a:solidFill>
                 <a:latin typeface="Calibri"/>
               </a:rPr>
@@ -7886,7 +8696,7 @@
             <a:r>
               <a:rPr sz="1100" b="0" i="1" dirty="0" err="1">
                 <a:solidFill>
-                  <a:srgbClr val="554B6E"/>
+                  <a:srgbClr val="C77DFF"/>
                 </a:solidFill>
                 <a:latin typeface="Calibri"/>
               </a:rPr>
@@ -7895,7 +8705,7 @@
             <a:r>
               <a:rPr sz="1100" b="0" i="1" dirty="0">
                 <a:solidFill>
-                  <a:srgbClr val="554B6E"/>
+                  <a:srgbClr val="C77DFF"/>
                 </a:solidFill>
                 <a:latin typeface="Calibri"/>
               </a:rPr>
@@ -7904,7 +8714,7 @@
             <a:r>
               <a:rPr lang="de-DE" sz="1100" b="0" i="1" dirty="0">
                 <a:solidFill>
-                  <a:srgbClr val="554B6E"/>
+                  <a:srgbClr val="C77DFF"/>
                 </a:solidFill>
                 <a:latin typeface="Calibri"/>
               </a:rPr>
@@ -7913,7 +8723,7 @@
             <a:r>
               <a:rPr sz="1100" b="0" i="1" dirty="0">
                 <a:solidFill>
-                  <a:srgbClr val="554B6E"/>
+                  <a:srgbClr val="C77DFF"/>
                 </a:solidFill>
                 <a:latin typeface="Calibri"/>
               </a:rPr>
@@ -7922,7 +8732,7 @@
             <a:r>
               <a:rPr sz="1100" b="0" i="1" dirty="0" err="1">
                 <a:solidFill>
-                  <a:srgbClr val="554B6E"/>
+                  <a:srgbClr val="C77DFF"/>
                 </a:solidFill>
                 <a:latin typeface="Calibri"/>
               </a:rPr>
@@ -7931,7 +8741,7 @@
             <a:r>
               <a:rPr sz="1100" b="0" i="1" dirty="0">
                 <a:solidFill>
-                  <a:srgbClr val="554B6E"/>
+                  <a:srgbClr val="C77DFF"/>
                 </a:solidFill>
                 <a:latin typeface="Calibri"/>
               </a:rPr>
@@ -7940,7 +8750,7 @@
             <a:r>
               <a:rPr sz="1100" b="0" i="1" dirty="0" err="1">
                 <a:solidFill>
-                  <a:srgbClr val="554B6E"/>
+                  <a:srgbClr val="C77DFF"/>
                 </a:solidFill>
                 <a:latin typeface="Calibri"/>
               </a:rPr>
@@ -7949,7 +8759,7 @@
             <a:r>
               <a:rPr sz="1100" b="0" i="1" dirty="0">
                 <a:solidFill>
-                  <a:srgbClr val="554B6E"/>
+                  <a:srgbClr val="C77DFF"/>
                 </a:solidFill>
                 <a:latin typeface="Calibri"/>
               </a:rPr>
@@ -8023,12 +8833,102 @@
           </a:prstGeom>
         </p:spPr>
       </p:pic>
+      <p:sp>
+        <p:nvSpPr>
+          <p:cNvPr id="14" name="AutoShape 2">
+            <a:extLst>
+              <a:ext uri="{FF2B5EF4-FFF2-40B4-BE49-F238E27FC236}">
+                <a16:creationId xmlns:a16="http://schemas.microsoft.com/office/drawing/2014/main" id="{B7BA2CE0-A3C3-43CF-AFDE-4960513DBBF9}"/>
+              </a:ext>
+            </a:extLst>
+          </p:cNvPr>
+          <p:cNvSpPr>
+            <a:spLocks noChangeAspect="1" noChangeArrowheads="1"/>
+          </p:cNvSpPr>
+          <p:nvPr/>
+        </p:nvSpPr>
+        <p:spPr bwMode="auto">
+          <a:xfrm>
+            <a:off x="5943600" y="3276600"/>
+            <a:ext cx="304800" cy="304800"/>
+          </a:xfrm>
+          <a:prstGeom prst="rect">
+            <a:avLst/>
+          </a:prstGeom>
+          <a:noFill/>
+          <a:extLst>
+            <a:ext uri="{909E8E84-426E-40DD-AFC4-6F175D3DCCD1}">
+              <a14:hiddenFill xmlns:a14="http://schemas.microsoft.com/office/drawing/2010/main">
+                <a:solidFill>
+                  <a:srgbClr val="FFFFFF"/>
+                </a:solidFill>
+              </a14:hiddenFill>
+            </a:ext>
+          </a:extLst>
+        </p:spPr>
+        <p:txBody>
+          <a:bodyPr vert="horz" wrap="square" lIns="91440" tIns="45720" rIns="91440" bIns="45720" numCol="1" anchor="t" anchorCtr="0" compatLnSpc="1">
+            <a:prstTxWarp prst="textNoShape">
+              <a:avLst/>
+            </a:prstTxWarp>
+          </a:bodyPr>
+          <a:lstStyle/>
+          <a:p>
+            <a:endParaRPr lang="de-DE"/>
+          </a:p>
+        </p:txBody>
+      </p:sp>
+      <p:sp>
+        <p:nvSpPr>
+          <p:cNvPr id="15" name="AutoShape 4">
+            <a:extLst>
+              <a:ext uri="{FF2B5EF4-FFF2-40B4-BE49-F238E27FC236}">
+                <a16:creationId xmlns:a16="http://schemas.microsoft.com/office/drawing/2014/main" id="{3A9D0566-524C-40F1-9D89-8F237246A7FE}"/>
+              </a:ext>
+            </a:extLst>
+          </p:cNvPr>
+          <p:cNvSpPr>
+            <a:spLocks noChangeAspect="1" noChangeArrowheads="1"/>
+          </p:cNvSpPr>
+          <p:nvPr/>
+        </p:nvSpPr>
+        <p:spPr bwMode="auto">
+          <a:xfrm>
+            <a:off x="6096000" y="3429000"/>
+            <a:ext cx="304800" cy="304800"/>
+          </a:xfrm>
+          <a:prstGeom prst="rect">
+            <a:avLst/>
+          </a:prstGeom>
+          <a:noFill/>
+          <a:extLst>
+            <a:ext uri="{909E8E84-426E-40DD-AFC4-6F175D3DCCD1}">
+              <a14:hiddenFill xmlns:a14="http://schemas.microsoft.com/office/drawing/2010/main">
+                <a:solidFill>
+                  <a:srgbClr val="FFFFFF"/>
+                </a:solidFill>
+              </a14:hiddenFill>
+            </a:ext>
+          </a:extLst>
+        </p:spPr>
+        <p:txBody>
+          <a:bodyPr vert="horz" wrap="square" lIns="91440" tIns="45720" rIns="91440" bIns="45720" numCol="1" anchor="t" anchorCtr="0" compatLnSpc="1">
+            <a:prstTxWarp prst="textNoShape">
+              <a:avLst/>
+            </a:prstTxWarp>
+          </a:bodyPr>
+          <a:lstStyle/>
+          <a:p>
+            <a:endParaRPr lang="de-DE"/>
+          </a:p>
+        </p:txBody>
+      </p:sp>
       <p:pic>
         <p:nvPicPr>
-          <p:cNvPr id="12" name="Grafik 11">
+          <p:cNvPr id="19" name="Grafik 18">
             <a:extLst>
               <a:ext uri="{FF2B5EF4-FFF2-40B4-BE49-F238E27FC236}">
-                <a16:creationId xmlns:a16="http://schemas.microsoft.com/office/drawing/2014/main" id="{E6EC975C-D8C6-0588-781F-0B0135AFEBCA}"/>
+                <a16:creationId xmlns:a16="http://schemas.microsoft.com/office/drawing/2014/main" id="{13A85422-850C-428D-8575-7BCCE9341F70}"/>
               </a:ext>
             </a:extLst>
           </p:cNvPr>
@@ -8038,19 +8938,93 @@
           <p:nvPr/>
         </p:nvPicPr>
         <p:blipFill>
-          <a:blip r:embed="rId4"/>
+          <a:blip r:embed="rId4">
+            <a:extLst>
+              <a:ext uri="{BEBA8EAE-BF5A-486C-A8C5-ECC9F3942E4B}">
+                <a14:imgProps xmlns:a14="http://schemas.microsoft.com/office/drawing/2010/main">
+                  <a14:imgLayer r:embed="rId5">
+                    <a14:imgEffect>
+                      <a14:sharpenSoften amount="-100000"/>
+                    </a14:imgEffect>
+                    <a14:imgEffect>
+                      <a14:colorTemperature colorTemp="6300"/>
+                    </a14:imgEffect>
+                    <a14:imgEffect>
+                      <a14:saturation sat="400000"/>
+                    </a14:imgEffect>
+                  </a14:imgLayer>
+                </a14:imgProps>
+              </a:ext>
+            </a:extLst>
+          </a:blip>
           <a:stretch>
             <a:fillRect/>
           </a:stretch>
         </p:blipFill>
         <p:spPr>
           <a:xfrm>
-            <a:off x="7812841" y="3917158"/>
-            <a:ext cx="285790" cy="71721"/>
-          </a:xfrm>
-          <a:prstGeom prst="rect">
-            <a:avLst/>
-          </a:prstGeom>
+            <a:off x="3374592" y="1078345"/>
+            <a:ext cx="5572125" cy="6858000"/>
+          </a:xfrm>
+          <a:prstGeom prst="rect">
+            <a:avLst/>
+          </a:prstGeom>
+          <a:effectLst>
+            <a:outerShdw blurRad="50800" dist="38100" dir="2700000" algn="tl" rotWithShape="0">
+              <a:prstClr val="black">
+                <a:alpha val="40000"/>
+              </a:prstClr>
+            </a:outerShdw>
+          </a:effectLst>
+        </p:spPr>
+      </p:pic>
+      <p:pic>
+        <p:nvPicPr>
+          <p:cNvPr id="18" name="Grafik 17">
+            <a:extLst>
+              <a:ext uri="{FF2B5EF4-FFF2-40B4-BE49-F238E27FC236}">
+                <a16:creationId xmlns:a16="http://schemas.microsoft.com/office/drawing/2014/main" id="{F676F69B-AE43-4435-9BD6-83BD2E379C8D}"/>
+              </a:ext>
+            </a:extLst>
+          </p:cNvPr>
+          <p:cNvPicPr>
+            <a:picLocks noChangeAspect="1"/>
+          </p:cNvPicPr>
+          <p:nvPr/>
+        </p:nvPicPr>
+        <p:blipFill>
+          <a:blip r:embed="rId6">
+            <a:extLst>
+              <a:ext uri="{BEBA8EAE-BF5A-486C-A8C5-ECC9F3942E4B}">
+                <a14:imgProps xmlns:a14="http://schemas.microsoft.com/office/drawing/2010/main">
+                  <a14:imgLayer r:embed="rId5">
+                    <a14:imgEffect>
+                      <a14:brightnessContrast bright="-1000" contrast="-33000"/>
+                    </a14:imgEffect>
+                  </a14:imgLayer>
+                </a14:imgProps>
+              </a:ext>
+            </a:extLst>
+          </a:blip>
+          <a:stretch>
+            <a:fillRect/>
+          </a:stretch>
+        </p:blipFill>
+        <p:spPr>
+          <a:xfrm>
+            <a:off x="3388593" y="1071706"/>
+            <a:ext cx="5572125" cy="6858000"/>
+          </a:xfrm>
+          <a:prstGeom prst="rect">
+            <a:avLst/>
+          </a:prstGeom>
+          <a:effectLst>
+            <a:outerShdw blurRad="50800" dist="38100" dir="2700000" algn="tl" rotWithShape="0">
+              <a:prstClr val="black">
+                <a:alpha val="40000"/>
+              </a:prstClr>
+            </a:outerShdw>
+          </a:effectLst>
         </p:spPr>
       </p:pic>
     </p:spTree>
@@ -8058,6 +9032,18 @@
   <p:clrMapOvr>
     <a:masterClrMapping/>
   </p:clrMapOvr>
+  <mc:AlternateContent xmlns:mc="http://schemas.openxmlformats.org/markup-compatibility/2006" xmlns:p159="http://schemas.microsoft.com/office/powerpoint/2015/09/main">
+    <mc:Choice Requires="p159">
+      <p:transition xmlns:p14="http://schemas.microsoft.com/office/powerpoint/2010/main" spd="slow" p14:dur="2000">
+        <p159:morph option="byObject"/>
+      </p:transition>
+    </mc:Choice>
+    <mc:Fallback xmlns="">
+      <p:transition spd="slow">
+        <p:fade/>
+      </p:transition>
+    </mc:Fallback>
+  </mc:AlternateContent>
 </p:sld>
 </file>
 
@@ -8086,14 +9072,14 @@
         </p:nvSpPr>
         <p:spPr>
           <a:xfrm>
-            <a:off x="0" y="0"/>
-            <a:ext cx="12191695" cy="6858000"/>
+            <a:off x="-1906" y="3586"/>
+            <a:ext cx="12191695" cy="6854414"/>
           </a:xfrm>
           <a:prstGeom prst="rect">
             <a:avLst/>
           </a:prstGeom>
           <a:solidFill>
-            <a:srgbClr val="140E29"/>
+            <a:srgbClr val="1F163A"/>
           </a:solidFill>
           <a:ln>
             <a:noFill/>
@@ -8119,7 +9105,7 @@
           <a:lstStyle/>
           <a:p>
             <a:pPr algn="ctr"/>
-            <a:endParaRPr/>
+            <a:endParaRPr dirty="0"/>
           </a:p>
         </p:txBody>
       </p:sp>
@@ -8211,7 +9197,7 @@
         <p:spPr>
           <a:xfrm>
             <a:off x="640080" y="1463040"/>
-            <a:ext cx="6400800" cy="1463040"/>
+            <a:ext cx="6400800" cy="1969770"/>
           </a:xfrm>
           <a:prstGeom prst="rect">
             <a:avLst/>
@@ -8226,49 +9212,14 @@
           <a:p>
             <a:pPr algn="l"/>
             <a:r>
-              <a:rPr sz="6400" b="1" i="0">
+              <a:rPr sz="6400" b="1" i="0" dirty="0">
                 <a:solidFill>
                   <a:srgbClr val="FFFFFF"/>
                 </a:solidFill>
                 <a:latin typeface="Calibri"/>
               </a:rPr>
               <a:t>Live-
-Demonstration.</a:t>
-            </a:r>
-          </a:p>
-        </p:txBody>
-      </p:sp>
-      <p:sp>
-        <p:nvSpPr>
-          <p:cNvPr id="6" name="TextBox 5"/>
-          <p:cNvSpPr txBox="1"/>
-          <p:nvPr/>
-        </p:nvSpPr>
-        <p:spPr>
-          <a:xfrm>
-            <a:off x="640080" y="3657600"/>
-            <a:ext cx="6400800" cy="457200"/>
-          </a:xfrm>
-          <a:prstGeom prst="rect">
-            <a:avLst/>
-          </a:prstGeom>
-          <a:noFill/>
-        </p:spPr>
-        <p:txBody>
-          <a:bodyPr wrap="square" lIns="0" tIns="0" rIns="0" bIns="0" anchor="t">
-            <a:spAutoFit/>
-          </a:bodyPr>
-          <a:lstStyle/>
-          <a:p>
-            <a:pPr algn="l"/>
-            <a:r>
-              <a:rPr sz="1500" b="0" i="1">
-                <a:solidFill>
-                  <a:srgbClr val="C77DFF"/>
-                </a:solidFill>
-                <a:latin typeface="Calibri"/>
-              </a:rPr>
-              <a:t>Sechs Stationen quer durch die Plattform — von der Linkpage bis ins Mod-Dashboard.</a:t>
+Demonstration</a:t>
             </a:r>
           </a:p>
         </p:txBody>
@@ -8602,7 +9553,7 @@
         <p:spPr>
           <a:xfrm>
             <a:off x="8092440" y="2350008"/>
-            <a:ext cx="3383280" cy="365760"/>
+            <a:ext cx="3383280" cy="230832"/>
           </a:xfrm>
           <a:prstGeom prst="rect">
             <a:avLst/>
@@ -8617,14 +9568,38 @@
           <a:p>
             <a:pPr algn="l"/>
             <a:r>
-              <a:rPr sz="1500" b="1" i="0">
+              <a:rPr lang="de-DE" sz="1500" b="1" i="0" dirty="0">
                 <a:solidFill>
                   <a:srgbClr val="FFFFFF"/>
                 </a:solidFill>
                 <a:latin typeface="Calibri"/>
               </a:rPr>
-              <a:t>Bartclicker</a:t>
-            </a:r>
+              <a:t>C</a:t>
+            </a:r>
+            <a:r>
+              <a:rPr sz="1500" b="1" i="0" dirty="0">
+                <a:solidFill>
+                  <a:srgbClr val="FFFFFF"/>
+                </a:solidFill>
+                <a:latin typeface="Calibri"/>
+              </a:rPr>
+              <a:t>licker</a:t>
+            </a:r>
+            <a:r>
+              <a:rPr lang="de-DE" sz="1500" b="1" i="0" dirty="0">
+                <a:solidFill>
+                  <a:srgbClr val="FFFFFF"/>
+                </a:solidFill>
+                <a:latin typeface="Calibri"/>
+              </a:rPr>
+              <a:t>-Game</a:t>
+            </a:r>
+            <a:endParaRPr sz="1500" b="1" i="0" dirty="0">
+              <a:solidFill>
+                <a:srgbClr val="FFFFFF"/>
+              </a:solidFill>
+              <a:latin typeface="Calibri"/>
+            </a:endParaRPr>
           </a:p>
         </p:txBody>
       </p:sp>
@@ -8992,7 +9967,7 @@
         <p:spPr>
           <a:xfrm>
             <a:off x="8092440" y="4123944"/>
-            <a:ext cx="3383280" cy="365760"/>
+            <a:ext cx="3383280" cy="230832"/>
           </a:xfrm>
           <a:prstGeom prst="rect">
             <a:avLst/>
@@ -9007,14 +9982,20 @@
           <a:p>
             <a:pPr algn="l"/>
             <a:r>
-              <a:rPr sz="1500" b="1" i="0">
+              <a:rPr lang="de-DE" sz="1500" b="1" i="0" dirty="0">
                 <a:solidFill>
                   <a:srgbClr val="FFFFFF"/>
                 </a:solidFill>
                 <a:latin typeface="Calibri"/>
               </a:rPr>
-              <a:t>OnlyBart</a:t>
-            </a:r>
+              <a:t>Premium-Bereich</a:t>
+            </a:r>
+            <a:endParaRPr sz="1500" b="1" i="0" dirty="0">
+              <a:solidFill>
+                <a:srgbClr val="FFFFFF"/>
+              </a:solidFill>
+              <a:latin typeface="Calibri"/>
+            </a:endParaRPr>
           </a:p>
         </p:txBody>
       </p:sp>
@@ -9452,7 +10433,7 @@
         <p:spPr>
           <a:xfrm>
             <a:off x="640080" y="6080760"/>
-            <a:ext cx="6400800" cy="365760"/>
+            <a:ext cx="6400800" cy="276999"/>
           </a:xfrm>
           <a:prstGeom prst="rect">
             <a:avLst/>
@@ -9467,14 +10448,61 @@
           <a:p>
             <a:pPr algn="l"/>
             <a:r>
-              <a:rPr sz="1800" b="1" i="0">
+              <a:rPr sz="1800" b="1" i="0" dirty="0">
                 <a:solidFill>
                   <a:srgbClr val="C77DFF"/>
                 </a:solidFill>
                 <a:latin typeface="Calibri"/>
               </a:rPr>
-              <a:t>→ www.hd1920x1080.de</a:t>
-            </a:r>
+              <a:t>→ </a:t>
+            </a:r>
+            <a:r>
+              <a:rPr sz="1800" b="1" i="0" dirty="0">
+                <a:solidFill>
+                  <a:srgbClr val="C77DFF"/>
+                </a:solidFill>
+                <a:latin typeface="Calibri"/>
+                <a:hlinkClick r:id="rId2">
+                  <a:extLst>
+                    <a:ext uri="{A12FA001-AC4F-418D-AE19-62706E023703}">
+                      <ahyp:hlinkClr xmlns:ahyp="http://schemas.microsoft.com/office/drawing/2018/hyperlinkcolor" val="tx"/>
+                    </a:ext>
+                  </a:extLst>
+                </a:hlinkClick>
+              </a:rPr>
+              <a:t>www.hd1920x1080.d</a:t>
+            </a:r>
+            <a:r>
+              <a:rPr lang="de-DE" sz="1800" b="1" i="0" dirty="0">
+                <a:solidFill>
+                  <a:srgbClr val="C77DFF"/>
+                </a:solidFill>
+                <a:latin typeface="Calibri"/>
+                <a:hlinkClick r:id="rId2">
+                  <a:extLst>
+                    <a:ext uri="{A12FA001-AC4F-418D-AE19-62706E023703}">
+                      <ahyp:hlinkClr xmlns:ahyp="http://schemas.microsoft.com/office/drawing/2018/hyperlinkcolor" val="tx"/>
+                    </a:ext>
+                  </a:extLst>
+                </a:hlinkClick>
+              </a:rPr>
+              <a:t>e</a:t>
+            </a:r>
+            <a:r>
+              <a:rPr lang="de-DE" sz="1800" b="1" i="0" dirty="0">
+                <a:solidFill>
+                  <a:srgbClr val="C77DFF"/>
+                </a:solidFill>
+                <a:latin typeface="Calibri"/>
+              </a:rPr>
+              <a:t> </a:t>
+            </a:r>
+            <a:endParaRPr sz="1800" b="1" i="0" dirty="0">
+              <a:solidFill>
+                <a:srgbClr val="C77DFF"/>
+              </a:solidFill>
+              <a:latin typeface="Calibri"/>
+            </a:endParaRPr>
           </a:p>
         </p:txBody>
       </p:sp>
@@ -9513,11 +10541,143 @@
           </a:p>
         </p:txBody>
       </p:sp>
+      <p:sp>
+        <p:nvSpPr>
+          <p:cNvPr id="39" name="AutoShape 2">
+            <a:extLst>
+              <a:ext uri="{FF2B5EF4-FFF2-40B4-BE49-F238E27FC236}">
+                <a16:creationId xmlns:a16="http://schemas.microsoft.com/office/drawing/2014/main" id="{4FE8BAB0-5336-4B2B-8423-49677119C7DA}"/>
+              </a:ext>
+            </a:extLst>
+          </p:cNvPr>
+          <p:cNvSpPr>
+            <a:spLocks noChangeAspect="1" noChangeArrowheads="1"/>
+          </p:cNvSpPr>
+          <p:nvPr/>
+        </p:nvSpPr>
+        <p:spPr bwMode="auto">
+          <a:xfrm>
+            <a:off x="5943600" y="3276600"/>
+            <a:ext cx="304800" cy="304800"/>
+          </a:xfrm>
+          <a:prstGeom prst="rect">
+            <a:avLst/>
+          </a:prstGeom>
+          <a:noFill/>
+          <a:extLst>
+            <a:ext uri="{909E8E84-426E-40DD-AFC4-6F175D3DCCD1}">
+              <a14:hiddenFill xmlns:a14="http://schemas.microsoft.com/office/drawing/2010/main">
+                <a:solidFill>
+                  <a:srgbClr val="FFFFFF"/>
+                </a:solidFill>
+              </a14:hiddenFill>
+            </a:ext>
+          </a:extLst>
+        </p:spPr>
+        <p:txBody>
+          <a:bodyPr vert="horz" wrap="square" lIns="91440" tIns="45720" rIns="91440" bIns="45720" numCol="1" anchor="t" anchorCtr="0" compatLnSpc="1">
+            <a:prstTxWarp prst="textNoShape">
+              <a:avLst/>
+            </a:prstTxWarp>
+          </a:bodyPr>
+          <a:lstStyle/>
+          <a:p>
+            <a:endParaRPr lang="de-DE"/>
+          </a:p>
+        </p:txBody>
+      </p:sp>
+      <p:sp>
+        <p:nvSpPr>
+          <p:cNvPr id="40" name="AutoShape 4">
+            <a:extLst>
+              <a:ext uri="{FF2B5EF4-FFF2-40B4-BE49-F238E27FC236}">
+                <a16:creationId xmlns:a16="http://schemas.microsoft.com/office/drawing/2014/main" id="{922EFC10-8D70-4E0A-8921-D4C13D87603C}"/>
+              </a:ext>
+            </a:extLst>
+          </p:cNvPr>
+          <p:cNvSpPr>
+            <a:spLocks noChangeAspect="1" noChangeArrowheads="1"/>
+          </p:cNvSpPr>
+          <p:nvPr/>
+        </p:nvSpPr>
+        <p:spPr bwMode="auto">
+          <a:xfrm>
+            <a:off x="6095999" y="3428999"/>
+            <a:ext cx="3777673" cy="3777673"/>
+          </a:xfrm>
+          <a:prstGeom prst="rect">
+            <a:avLst/>
+          </a:prstGeom>
+          <a:noFill/>
+          <a:extLst>
+            <a:ext uri="{909E8E84-426E-40DD-AFC4-6F175D3DCCD1}">
+              <a14:hiddenFill xmlns:a14="http://schemas.microsoft.com/office/drawing/2010/main">
+                <a:solidFill>
+                  <a:srgbClr val="FFFFFF"/>
+                </a:solidFill>
+              </a14:hiddenFill>
+            </a:ext>
+          </a:extLst>
+        </p:spPr>
+        <p:txBody>
+          <a:bodyPr vert="horz" wrap="square" lIns="91440" tIns="45720" rIns="91440" bIns="45720" numCol="1" anchor="t" anchorCtr="0" compatLnSpc="1">
+            <a:prstTxWarp prst="textNoShape">
+              <a:avLst/>
+            </a:prstTxWarp>
+          </a:bodyPr>
+          <a:lstStyle/>
+          <a:p>
+            <a:endParaRPr lang="de-DE"/>
+          </a:p>
+        </p:txBody>
+      </p:sp>
+      <p:pic>
+        <p:nvPicPr>
+          <p:cNvPr id="42" name="Grafik 41">
+            <a:extLst>
+              <a:ext uri="{FF2B5EF4-FFF2-40B4-BE49-F238E27FC236}">
+                <a16:creationId xmlns:a16="http://schemas.microsoft.com/office/drawing/2014/main" id="{D7522987-BF1A-4E62-A62D-11CDC52D0CBC}"/>
+              </a:ext>
+            </a:extLst>
+          </p:cNvPr>
+          <p:cNvPicPr>
+            <a:picLocks noChangeAspect="1"/>
+          </p:cNvPicPr>
+          <p:nvPr/>
+        </p:nvPicPr>
+        <p:blipFill>
+          <a:blip r:embed="rId3"/>
+          <a:stretch>
+            <a:fillRect/>
+          </a:stretch>
+        </p:blipFill>
+        <p:spPr>
+          <a:xfrm>
+            <a:off x="3627325" y="4013718"/>
+            <a:ext cx="2725907" cy="2725907"/>
+          </a:xfrm>
+          <a:prstGeom prst="rect">
+            <a:avLst/>
+          </a:prstGeom>
+        </p:spPr>
+      </p:pic>
     </p:spTree>
   </p:cSld>
   <p:clrMapOvr>
     <a:masterClrMapping/>
   </p:clrMapOvr>
+  <mc:AlternateContent xmlns:mc="http://schemas.openxmlformats.org/markup-compatibility/2006" xmlns:p159="http://schemas.microsoft.com/office/powerpoint/2015/09/main">
+    <mc:Choice Requires="p159">
+      <p:transition xmlns:p14="http://schemas.microsoft.com/office/powerpoint/2010/main" spd="slow" p14:dur="2000">
+        <p159:morph option="byObject"/>
+      </p:transition>
+    </mc:Choice>
+    <mc:Fallback xmlns="">
+      <p:transition spd="slow">
+        <p:fade/>
+      </p:transition>
+    </mc:Fallback>
+  </mc:AlternateContent>
 </p:sld>
 </file>
 
@@ -9671,7 +10831,7 @@
         <p:spPr>
           <a:xfrm>
             <a:off x="640080" y="914400"/>
-            <a:ext cx="10058400" cy="914400"/>
+            <a:ext cx="10058400" cy="553998"/>
           </a:xfrm>
           <a:prstGeom prst="rect">
             <a:avLst/>
@@ -9686,14 +10846,29 @@
           <a:p>
             <a:pPr algn="l"/>
             <a:r>
-              <a:rPr sz="3600" b="1" i="0">
+              <a:rPr sz="3600" b="1" i="0" dirty="0">
                 <a:solidFill>
                   <a:srgbClr val="FFFFFF"/>
                 </a:solidFill>
                 <a:latin typeface="Calibri"/>
               </a:rPr>
-              <a:t>Highlights und Herausforderungen.</a:t>
-            </a:r>
+              <a:t>Highlights und </a:t>
+            </a:r>
+            <a:r>
+              <a:rPr sz="3600" b="1" i="0" dirty="0" err="1">
+                <a:solidFill>
+                  <a:srgbClr val="FFFFFF"/>
+                </a:solidFill>
+                <a:latin typeface="Calibri"/>
+              </a:rPr>
+              <a:t>Herausforderungen</a:t>
+            </a:r>
+            <a:endParaRPr sz="3600" b="1" i="0" dirty="0">
+              <a:solidFill>
+                <a:srgbClr val="FFFFFF"/>
+              </a:solidFill>
+              <a:latin typeface="Calibri"/>
+            </a:endParaRPr>
           </a:p>
         </p:txBody>
       </p:sp>
@@ -10068,7 +11243,7 @@
         <p:spPr>
           <a:xfrm>
             <a:off x="1188720" y="4526280"/>
-            <a:ext cx="4663440" cy="457200"/>
+            <a:ext cx="4663440" cy="215444"/>
           </a:xfrm>
           <a:prstGeom prst="rect">
             <a:avLst/>
@@ -10083,13 +11258,13 @@
           <a:p>
             <a:pPr algn="l"/>
             <a:r>
-              <a:rPr sz="1400" b="0" i="0">
+              <a:rPr sz="1400" b="0" i="0" dirty="0">
                 <a:solidFill>
                   <a:srgbClr val="FFFFFF"/>
                 </a:solidFill>
                 <a:latin typeface="Calibri"/>
               </a:rPr>
-              <a:t>Bun-Bot mit ~64 MB RAM (statt JVM/Spring)</a:t>
+              <a:t>Bun-Bot</a:t>
             </a:r>
           </a:p>
         </p:txBody>
@@ -10689,6 +11864,18 @@
   <p:clrMapOvr>
     <a:masterClrMapping/>
   </p:clrMapOvr>
+  <mc:AlternateContent xmlns:mc="http://schemas.openxmlformats.org/markup-compatibility/2006" xmlns:p159="http://schemas.microsoft.com/office/powerpoint/2015/09/main">
+    <mc:Choice Requires="p159">
+      <p:transition xmlns:p14="http://schemas.microsoft.com/office/powerpoint/2010/main" spd="slow" p14:dur="2000">
+        <p159:morph option="byObject"/>
+      </p:transition>
+    </mc:Choice>
+    <mc:Fallback xmlns="">
+      <p:transition spd="slow">
+        <p:fade/>
+      </p:transition>
+    </mc:Fallback>
+  </mc:AlternateContent>
 </p:sld>
 </file>
 
@@ -10724,7 +11911,7 @@
             <a:avLst/>
           </a:prstGeom>
           <a:solidFill>
-            <a:srgbClr val="140E29"/>
+            <a:srgbClr val="1F163A"/>
           </a:solidFill>
           <a:ln>
             <a:noFill/>
@@ -10886,7 +12073,7 @@
         <p:spPr>
           <a:xfrm>
             <a:off x="4114800" y="1371600"/>
-            <a:ext cx="7589520" cy="1371600"/>
+            <a:ext cx="7589520" cy="1107996"/>
           </a:xfrm>
           <a:prstGeom prst="rect">
             <a:avLst/>
@@ -10901,14 +12088,20 @@
           <a:p>
             <a:pPr algn="l"/>
             <a:r>
-              <a:rPr sz="7200" b="1" i="0">
+              <a:rPr sz="7200" b="1" i="0" dirty="0" err="1">
                 <a:solidFill>
                   <a:srgbClr val="FFFFFF"/>
                 </a:solidFill>
                 <a:latin typeface="Calibri"/>
               </a:rPr>
-              <a:t>Fazit.</a:t>
-            </a:r>
+              <a:t>Fazit</a:t>
+            </a:r>
+            <a:endParaRPr sz="7200" b="1" i="0" dirty="0">
+              <a:solidFill>
+                <a:srgbClr val="FFFFFF"/>
+              </a:solidFill>
+              <a:latin typeface="Calibri"/>
+            </a:endParaRPr>
           </a:p>
         </p:txBody>
       </p:sp>
@@ -11263,7 +12456,7 @@
         <p:spPr>
           <a:xfrm>
             <a:off x="4434840" y="5449824"/>
-            <a:ext cx="7040880" cy="365760"/>
+            <a:ext cx="7040880" cy="184666"/>
           </a:xfrm>
           <a:prstGeom prst="rect">
             <a:avLst/>
@@ -11278,13 +12471,112 @@
           <a:p>
             <a:pPr algn="l"/>
             <a:r>
-              <a:rPr sz="1200" b="0" i="1">
+              <a:rPr sz="1200" b="0" i="1" dirty="0" err="1">
                 <a:solidFill>
                   <a:srgbClr val="B6A8D3"/>
                 </a:solidFill>
                 <a:latin typeface="Calibri"/>
               </a:rPr>
-              <a:t>Neuer Streamer = setup.exe ausführen, nicht den Quellcode forken.</a:t>
+              <a:t>Neuer</a:t>
+            </a:r>
+            <a:r>
+              <a:rPr sz="1200" b="0" i="1" dirty="0">
+                <a:solidFill>
+                  <a:srgbClr val="B6A8D3"/>
+                </a:solidFill>
+                <a:latin typeface="Calibri"/>
+              </a:rPr>
+              <a:t> Streamer</a:t>
+            </a:r>
+            <a:r>
+              <a:rPr lang="de-DE" sz="1200" b="0" i="1" dirty="0">
+                <a:solidFill>
+                  <a:srgbClr val="B6A8D3"/>
+                </a:solidFill>
+                <a:latin typeface="Calibri"/>
+              </a:rPr>
+              <a:t>: künftig</a:t>
+            </a:r>
+            <a:r>
+              <a:rPr sz="1200" b="0" i="1" dirty="0">
+                <a:solidFill>
+                  <a:srgbClr val="B6A8D3"/>
+                </a:solidFill>
+                <a:latin typeface="Calibri"/>
+              </a:rPr>
+              <a:t> setup.exe </a:t>
+            </a:r>
+            <a:r>
+              <a:rPr sz="1200" b="0" i="1" dirty="0" err="1">
+                <a:solidFill>
+                  <a:srgbClr val="B6A8D3"/>
+                </a:solidFill>
+                <a:latin typeface="Calibri"/>
+              </a:rPr>
+              <a:t>ausführen</a:t>
+            </a:r>
+            <a:r>
+              <a:rPr sz="1200" b="0" i="1" dirty="0">
+                <a:solidFill>
+                  <a:srgbClr val="B6A8D3"/>
+                </a:solidFill>
+                <a:latin typeface="Calibri"/>
+              </a:rPr>
+              <a:t>, </a:t>
+            </a:r>
+            <a:r>
+              <a:rPr sz="1200" b="0" i="1" dirty="0" err="1">
+                <a:solidFill>
+                  <a:srgbClr val="B6A8D3"/>
+                </a:solidFill>
+                <a:latin typeface="Calibri"/>
+              </a:rPr>
+              <a:t>nicht</a:t>
+            </a:r>
+            <a:r>
+              <a:rPr sz="1200" b="0" i="1" dirty="0">
+                <a:solidFill>
+                  <a:srgbClr val="B6A8D3"/>
+                </a:solidFill>
+                <a:latin typeface="Calibri"/>
+              </a:rPr>
+              <a:t> den </a:t>
+            </a:r>
+            <a:r>
+              <a:rPr sz="1200" b="0" i="1" dirty="0" err="1">
+                <a:solidFill>
+                  <a:srgbClr val="B6A8D3"/>
+                </a:solidFill>
+                <a:latin typeface="Calibri"/>
+              </a:rPr>
+              <a:t>Quellcode</a:t>
+            </a:r>
+            <a:r>
+              <a:rPr sz="1200" b="0" i="1" dirty="0">
+                <a:solidFill>
+                  <a:srgbClr val="B6A8D3"/>
+                </a:solidFill>
+                <a:latin typeface="Calibri"/>
+              </a:rPr>
+              <a:t> </a:t>
+            </a:r>
+            <a:r>
+              <a:rPr sz="1200" b="0" i="1" dirty="0" err="1">
+                <a:solidFill>
+                  <a:srgbClr val="B6A8D3"/>
+                </a:solidFill>
+                <a:latin typeface="Calibri"/>
+              </a:rPr>
+              <a:t>forken</a:t>
+            </a:r>
+            <a:r>
+              <a:rPr sz="1200" b="0" i="1" dirty="0">
+                <a:solidFill>
+                  <a:srgbClr val="B6A8D3"/>
+                </a:solidFill>
+                <a:latin typeface="Calibri"/>
+              </a:rPr>
+              <a:t>.</a:t>
             </a:r>
           </a:p>
         </p:txBody>
@@ -11313,7 +12605,7 @@
           <a:p>
             <a:pPr algn="l"/>
             <a:r>
-              <a:rPr sz="1100" b="0" i="0">
+              <a:rPr sz="1100" b="0" i="0" dirty="0">
                 <a:solidFill>
                   <a:srgbClr val="B6A8D3"/>
                 </a:solidFill>
@@ -11329,6 +12621,18 @@
   <p:clrMapOvr>
     <a:masterClrMapping/>
   </p:clrMapOvr>
+  <mc:AlternateContent xmlns:mc="http://schemas.openxmlformats.org/markup-compatibility/2006" xmlns:p159="http://schemas.microsoft.com/office/powerpoint/2015/09/main">
+    <mc:Choice Requires="p159">
+      <p:transition xmlns:p14="http://schemas.microsoft.com/office/powerpoint/2010/main" spd="slow" p14:dur="2000">
+        <p159:morph option="byObject"/>
+      </p:transition>
+    </mc:Choice>
+    <mc:Fallback xmlns="">
+      <p:transition spd="slow">
+        <p:fade/>
+      </p:transition>
+    </mc:Fallback>
+  </mc:AlternateContent>
 </p:sld>
 </file>
 
@@ -11650,4 +12954,299 @@
   </a:objectDefaults>
   <a:extraClrSchemeLst/>
 </a:theme>
+</file>
+
+<file path=ppt/theme/theme2.xml><?xml version="1.0" encoding="utf-8"?>
+<a:theme xmlns:a="http://schemas.openxmlformats.org/drawingml/2006/main" name="Office">
+  <a:themeElements>
+    <a:clrScheme name="Office">
+      <a:dk1>
+        <a:sysClr val="windowText" lastClr="000000"/>
+      </a:dk1>
+      <a:lt1>
+        <a:sysClr val="window" lastClr="FFFFFF"/>
+      </a:lt1>
+      <a:dk2>
+        <a:srgbClr val="44546A"/>
+      </a:dk2>
+      <a:lt2>
+        <a:srgbClr val="E7E6E6"/>
+      </a:lt2>
+      <a:accent1>
+        <a:srgbClr val="4472C4"/>
+      </a:accent1>
+      <a:accent2>
+        <a:srgbClr val="ED7D31"/>
+      </a:accent2>
+      <a:accent3>
+        <a:srgbClr val="A5A5A5"/>
+      </a:accent3>
+      <a:accent4>
+        <a:srgbClr val="FFC000"/>
+      </a:accent4>
+      <a:accent5>
+        <a:srgbClr val="5B9BD5"/>
+      </a:accent5>
+      <a:accent6>
+        <a:srgbClr val="70AD47"/>
+      </a:accent6>
+      <a:hlink>
+        <a:srgbClr val="0563C1"/>
+      </a:hlink>
+      <a:folHlink>
+        <a:srgbClr val="954F72"/>
+      </a:folHlink>
+    </a:clrScheme>
+    <a:fontScheme name="Office">
+      <a:majorFont>
+        <a:latin typeface="Calibri Light" panose="020F0302020204030204"/>
+        <a:ea typeface=""/>
+        <a:cs typeface=""/>
+        <a:font script="Jpan" typeface="游ゴシック Light"/>
+        <a:font script="Hang" typeface="맑은 고딕"/>
+        <a:font script="Hans" typeface="等线 Light"/>
+        <a:font script="Hant" typeface="新細明體"/>
+        <a:font script="Arab" typeface="Times New Roman"/>
+        <a:font script="Hebr" typeface="Times New Roman"/>
+        <a:font script="Thai" typeface="Angsana New"/>
+        <a:font script="Ethi" typeface="Nyala"/>
+        <a:font script="Beng" typeface="Vrinda"/>
+        <a:font script="Gujr" typeface="Shruti"/>
+        <a:font script="Khmr" typeface="MoolBoran"/>
+        <a:font script="Knda" typeface="Tunga"/>
+        <a:font script="Guru" typeface="Raavi"/>
+        <a:font script="Cans" typeface="Euphemia"/>
+        <a:font script="Cher" typeface="Plantagenet Cherokee"/>
+        <a:font script="Yiii" typeface="Microsoft Yi Baiti"/>
+        <a:font script="Tibt" typeface="Microsoft Himalaya"/>
+        <a:font script="Thaa" typeface="MV Boli"/>
+        <a:font script="Deva" typeface="Mangal"/>
+        <a:font script="Telu" typeface="Gautami"/>
+        <a:font script="Taml" typeface="Latha"/>
+        <a:font script="Syrc" typeface="Estrangelo Edessa"/>
+        <a:font script="Orya" typeface="Kalinga"/>
+        <a:font script="Mlym" typeface="Kartika"/>
+        <a:font script="Laoo" typeface="DokChampa"/>
+        <a:font script="Sinh" typeface="Iskoola Pota"/>
+        <a:font script="Mong" typeface="Mongolian Baiti"/>
+        <a:font script="Viet" typeface="Times New Roman"/>
+        <a:font script="Uigh" typeface="Microsoft Uighur"/>
+        <a:font script="Geor" typeface="Sylfaen"/>
+        <a:font script="Armn" typeface="Arial"/>
+        <a:font script="Bugi" typeface="Leelawadee UI"/>
+        <a:font script="Bopo" typeface="Microsoft JhengHei"/>
+        <a:font script="Java" typeface="Javanese Text"/>
+        <a:font script="Lisu" typeface="Segoe UI"/>
+        <a:font script="Mymr" typeface="Myanmar Text"/>
+        <a:font script="Nkoo" typeface="Ebrima"/>
+        <a:font script="Olck" typeface="Nirmala UI"/>
+        <a:font script="Osma" typeface="Ebrima"/>
+        <a:font script="Phag" typeface="Phagspa"/>
+        <a:font script="Syrn" typeface="Estrangelo Edessa"/>
+        <a:font script="Syrj" typeface="Estrangelo Edessa"/>
+        <a:font script="Syre" typeface="Estrangelo Edessa"/>
+        <a:font script="Sora" typeface="Nirmala UI"/>
+        <a:font script="Tale" typeface="Microsoft Tai Le"/>
+        <a:font script="Talu" typeface="Microsoft New Tai Lue"/>
+        <a:font script="Tfng" typeface="Ebrima"/>
+      </a:majorFont>
+      <a:minorFont>
+        <a:latin typeface="Calibri" panose="020F0502020204030204"/>
+        <a:ea typeface=""/>
+        <a:cs typeface=""/>
+        <a:font script="Jpan" typeface="游ゴシック"/>
+        <a:font script="Hang" typeface="맑은 고딕"/>
+        <a:font script="Hans" typeface="等线"/>
+        <a:font script="Hant" typeface="新細明體"/>
+        <a:font script="Arab" typeface="Arial"/>
+        <a:font script="Hebr" typeface="Arial"/>
+        <a:font script="Thai" typeface="Cordia New"/>
+        <a:font script="Ethi" typeface="Nyala"/>
+        <a:font script="Beng" typeface="Vrinda"/>
+        <a:font script="Gujr" typeface="Shruti"/>
+        <a:font script="Khmr" typeface="DaunPenh"/>
+        <a:font script="Knda" typeface="Tunga"/>
+        <a:font script="Guru" typeface="Raavi"/>
+        <a:font script="Cans" typeface="Euphemia"/>
+        <a:font script="Cher" typeface="Plantagenet Cherokee"/>
+        <a:font script="Yiii" typeface="Microsoft Yi Baiti"/>
+        <a:font script="Tibt" typeface="Microsoft Himalaya"/>
+        <a:font script="Thaa" typeface="MV Boli"/>
+        <a:font script="Deva" typeface="Mangal"/>
+        <a:font script="Telu" typeface="Gautami"/>
+        <a:font script="Taml" typeface="Latha"/>
+        <a:font script="Syrc" typeface="Estrangelo Edessa"/>
+        <a:font script="Orya" typeface="Kalinga"/>
+        <a:font script="Mlym" typeface="Kartika"/>
+        <a:font script="Laoo" typeface="DokChampa"/>
+        <a:font script="Sinh" typeface="Iskoola Pota"/>
+        <a:font script="Mong" typeface="Mongolian Baiti"/>
+        <a:font script="Viet" typeface="Arial"/>
+        <a:font script="Uigh" typeface="Microsoft Uighur"/>
+        <a:font script="Geor" typeface="Sylfaen"/>
+        <a:font script="Armn" typeface="Arial"/>
+        <a:font script="Bugi" typeface="Leelawadee UI"/>
+        <a:font script="Bopo" typeface="Microsoft JhengHei"/>
+        <a:font script="Java" typeface="Javanese Text"/>
+        <a:font script="Lisu" typeface="Segoe UI"/>
+        <a:font script="Mymr" typeface="Myanmar Text"/>
+        <a:font script="Nkoo" typeface="Ebrima"/>
+        <a:font script="Olck" typeface="Nirmala UI"/>
+        <a:font script="Osma" typeface="Ebrima"/>
+        <a:font script="Phag" typeface="Phagspa"/>
+        <a:font script="Syrn" typeface="Estrangelo Edessa"/>
+        <a:font script="Syrj" typeface="Estrangelo Edessa"/>
+        <a:font script="Syre" typeface="Estrangelo Edessa"/>
+        <a:font script="Sora" typeface="Nirmala UI"/>
+        <a:font script="Tale" typeface="Microsoft Tai Le"/>
+        <a:font script="Talu" typeface="Microsoft New Tai Lue"/>
+        <a:font script="Tfng" typeface="Ebrima"/>
+      </a:minorFont>
+    </a:fontScheme>
+    <a:fmtScheme name="Office">
+      <a:fillStyleLst>
+        <a:solidFill>
+          <a:schemeClr val="phClr"/>
+        </a:solidFill>
+        <a:gradFill rotWithShape="1">
+          <a:gsLst>
+            <a:gs pos="0">
+              <a:schemeClr val="phClr">
+                <a:lumMod val="110000"/>
+                <a:satMod val="105000"/>
+                <a:tint val="67000"/>
+              </a:schemeClr>
+            </a:gs>
+            <a:gs pos="50000">
+              <a:schemeClr val="phClr">
+                <a:lumMod val="105000"/>
+                <a:satMod val="103000"/>
+                <a:tint val="73000"/>
+              </a:schemeClr>
+            </a:gs>
+            <a:gs pos="100000">
+              <a:schemeClr val="phClr">
+                <a:lumMod val="105000"/>
+                <a:satMod val="109000"/>
+                <a:tint val="81000"/>
+              </a:schemeClr>
+            </a:gs>
+          </a:gsLst>
+          <a:lin ang="5400000" scaled="0"/>
+        </a:gradFill>
+        <a:gradFill rotWithShape="1">
+          <a:gsLst>
+            <a:gs pos="0">
+              <a:schemeClr val="phClr">
+                <a:satMod val="103000"/>
+                <a:lumMod val="102000"/>
+                <a:tint val="94000"/>
+              </a:schemeClr>
+            </a:gs>
+            <a:gs pos="50000">
+              <a:schemeClr val="phClr">
+                <a:satMod val="110000"/>
+                <a:lumMod val="100000"/>
+                <a:shade val="100000"/>
+              </a:schemeClr>
+            </a:gs>
+            <a:gs pos="100000">
+              <a:schemeClr val="phClr">
+                <a:lumMod val="99000"/>
+                <a:satMod val="120000"/>
+                <a:shade val="78000"/>
+              </a:schemeClr>
+            </a:gs>
+          </a:gsLst>
+          <a:lin ang="5400000" scaled="0"/>
+        </a:gradFill>
+      </a:fillStyleLst>
+      <a:lnStyleLst>
+        <a:ln w="6350" cap="flat" cmpd="sng" algn="ctr">
+          <a:solidFill>
+            <a:schemeClr val="phClr"/>
+          </a:solidFill>
+          <a:prstDash val="solid"/>
+          <a:miter lim="800000"/>
+        </a:ln>
+        <a:ln w="12700" cap="flat" cmpd="sng" algn="ctr">
+          <a:solidFill>
+            <a:schemeClr val="phClr"/>
+          </a:solidFill>
+          <a:prstDash val="solid"/>
+          <a:miter lim="800000"/>
+        </a:ln>
+        <a:ln w="19050" cap="flat" cmpd="sng" algn="ctr">
+          <a:solidFill>
+            <a:schemeClr val="phClr"/>
+          </a:solidFill>
+          <a:prstDash val="solid"/>
+          <a:miter lim="800000"/>
+        </a:ln>
+      </a:lnStyleLst>
+      <a:effectStyleLst>
+        <a:effectStyle>
+          <a:effectLst/>
+        </a:effectStyle>
+        <a:effectStyle>
+          <a:effectLst/>
+        </a:effectStyle>
+        <a:effectStyle>
+          <a:effectLst>
+            <a:outerShdw blurRad="57150" dist="19050" dir="5400000" algn="ctr" rotWithShape="0">
+              <a:srgbClr val="000000">
+                <a:alpha val="63000"/>
+              </a:srgbClr>
+            </a:outerShdw>
+          </a:effectLst>
+        </a:effectStyle>
+      </a:effectStyleLst>
+      <a:bgFillStyleLst>
+        <a:solidFill>
+          <a:schemeClr val="phClr"/>
+        </a:solidFill>
+        <a:solidFill>
+          <a:schemeClr val="phClr">
+            <a:tint val="95000"/>
+            <a:satMod val="170000"/>
+          </a:schemeClr>
+        </a:solidFill>
+        <a:gradFill rotWithShape="1">
+          <a:gsLst>
+            <a:gs pos="0">
+              <a:schemeClr val="phClr">
+                <a:tint val="93000"/>
+                <a:satMod val="150000"/>
+                <a:shade val="98000"/>
+                <a:lumMod val="102000"/>
+              </a:schemeClr>
+            </a:gs>
+            <a:gs pos="50000">
+              <a:schemeClr val="phClr">
+                <a:tint val="98000"/>
+                <a:satMod val="130000"/>
+                <a:shade val="90000"/>
+                <a:lumMod val="103000"/>
+              </a:schemeClr>
+            </a:gs>
+            <a:gs pos="100000">
+              <a:schemeClr val="phClr">
+                <a:shade val="63000"/>
+                <a:satMod val="120000"/>
+              </a:schemeClr>
+            </a:gs>
+          </a:gsLst>
+          <a:lin ang="5400000" scaled="0"/>
+        </a:gradFill>
+      </a:bgFillStyleLst>
+    </a:fmtScheme>
+  </a:themeElements>
+  <a:objectDefaults/>
+  <a:extraClrSchemeLst/>
+  <a:extLst>
+    <a:ext uri="{05A4C25C-085E-4340-85A3-A5531E510DB2}">
+      <thm15:themeFamily xmlns:thm15="http://schemas.microsoft.com/office/thememl/2012/main" name="Office Theme" id="{62F939B6-93AF-4DB8-9C6B-D6C7DFDC589F}" vid="{4A3C46E8-61CC-4603-A589-7422A47A8E4A}"/>
+    </a:ext>
+  </a:extLst>
+</a:theme>
 </file>
</xml_diff>

<commit_message>
feat!: breaking change in anticheat version in previous release
</commit_message>
<xml_diff>
--- a/_doku/Praesentation_TwitchLandingpage_v3.pptx
+++ b/_doku/Praesentation_TwitchLandingpage_v3.pptx
@@ -8536,7 +8536,7 @@
         </p:nvSpPr>
         <p:spPr>
           <a:xfrm>
-            <a:off x="305" y="0"/>
+            <a:off x="305" y="-9526"/>
             <a:ext cx="12191695" cy="6995160"/>
           </a:xfrm>
           <a:prstGeom prst="rect">
@@ -9025,6 +9025,36 @@
               </a:prstClr>
             </a:outerShdw>
           </a:effectLst>
+        </p:spPr>
+      </p:pic>
+      <p:pic>
+        <p:nvPicPr>
+          <p:cNvPr id="6" name="Grafik 5">
+            <a:extLst>
+              <a:ext uri="{FF2B5EF4-FFF2-40B4-BE49-F238E27FC236}">
+                <a16:creationId xmlns:a16="http://schemas.microsoft.com/office/drawing/2014/main" id="{A770D5FC-BA17-4E8B-BB00-58F515E6839F}"/>
+              </a:ext>
+            </a:extLst>
+          </p:cNvPr>
+          <p:cNvPicPr>
+            <a:picLocks noChangeAspect="1"/>
+          </p:cNvPicPr>
+          <p:nvPr/>
+        </p:nvPicPr>
+        <p:blipFill>
+          <a:blip r:embed="rId7"/>
+          <a:stretch>
+            <a:fillRect/>
+          </a:stretch>
+        </p:blipFill>
+        <p:spPr>
+          <a:xfrm>
+            <a:off x="8020018" y="4000521"/>
+            <a:ext cx="457264" cy="171474"/>
+          </a:xfrm>
+          <a:prstGeom prst="rect">
+            <a:avLst/>
+          </a:prstGeom>
         </p:spPr>
       </p:pic>
     </p:spTree>

</xml_diff>